<commit_message>
STEP 04 API 코드 예제 슬라이드 추가 (Python requests)
- 새 슬라이드: Device 등록 → 대화방 생성 → 메시지 전송 Python 예제
- 공통 헤더 설정 (BASE_URL, Authorization, x-system-id)
- ① POST /messenger/bot/v1/device → device_id 획득
- ② POST /messenger/bot/v1/chatroom → room_id 획득
- ③ POST /messenger/bot/v1/message → 텍스트 메시지 전송

https://claude.ai/code/session_01T97wq5dgMtUQadeWGjzCmF
</commit_message>
<xml_diff>
--- a/knox_chatbot_가이드.pptx
+++ b/knox_chatbot_가이드.pptx
@@ -13,6 +13,7 @@
     <p:sldId id="261" r:id="rId12"/>
     <p:sldId id="262" r:id="rId13"/>
     <p:sldId id="263" r:id="rId14"/>
+    <p:sldId id="264" r:id="rId15"/>
   </p:sldIdLst>
   <p:sldSz cx="12188952" cy="6858000" type="screen4x3"/>
   <p:notesSz cx="6858000" cy="9144000"/>
@@ -12092,6 +12093,1432 @@
 </file>
 
 <file path=ppt/slides/slide8.xml><?xml version="1.0" encoding="utf-8"?>
+<p:sld xmlns:a="http://schemas.openxmlformats.org/drawingml/2006/main" xmlns:p="http://schemas.openxmlformats.org/presentationml/2006/main" xmlns:r="http://schemas.openxmlformats.org/officeDocument/2006/relationships">
+  <p:cSld>
+    <p:spTree>
+      <p:nvGrpSpPr>
+        <p:cNvPr id="1" name=""/>
+        <p:cNvGrpSpPr/>
+        <p:nvPr/>
+      </p:nvGrpSpPr>
+      <p:grpSpPr/>
+      <p:sp>
+        <p:nvSpPr>
+          <p:cNvPr id="2" name="Rectangle 1"/>
+          <p:cNvSpPr/>
+          <p:nvPr/>
+        </p:nvSpPr>
+        <p:spPr>
+          <a:xfrm>
+            <a:off x="0" y="0"/>
+            <a:ext cx="12188952" cy="6858000"/>
+          </a:xfrm>
+          <a:prstGeom prst="rect">
+            <a:avLst/>
+          </a:prstGeom>
+          <a:solidFill>
+            <a:srgbClr val="0F172A"/>
+          </a:solidFill>
+          <a:ln>
+            <a:noFill/>
+          </a:ln>
+        </p:spPr>
+        <p:style>
+          <a:lnRef idx="1">
+            <a:schemeClr val="accent1"/>
+          </a:lnRef>
+          <a:fillRef idx="3">
+            <a:schemeClr val="accent1"/>
+          </a:fillRef>
+          <a:effectRef idx="2">
+            <a:schemeClr val="accent1"/>
+          </a:effectRef>
+          <a:fontRef idx="minor">
+            <a:schemeClr val="lt1"/>
+          </a:fontRef>
+        </p:style>
+        <p:txBody>
+          <a:bodyPr rtlCol="0" anchor="ctr"/>
+          <a:lstStyle/>
+          <a:p>
+            <a:pPr algn="ctr"/>
+          </a:p>
+        </p:txBody>
+      </p:sp>
+      <p:sp>
+        <p:nvSpPr>
+          <p:cNvPr id="3" name="Rectangle 2"/>
+          <p:cNvSpPr/>
+          <p:nvPr/>
+        </p:nvSpPr>
+        <p:spPr>
+          <a:xfrm>
+            <a:off x="0" y="0"/>
+            <a:ext cx="12188952" cy="91440"/>
+          </a:xfrm>
+          <a:prstGeom prst="rect">
+            <a:avLst/>
+          </a:prstGeom>
+          <a:solidFill>
+            <a:srgbClr val="38BDF8"/>
+          </a:solidFill>
+          <a:ln>
+            <a:noFill/>
+          </a:ln>
+        </p:spPr>
+        <p:style>
+          <a:lnRef idx="1">
+            <a:schemeClr val="accent1"/>
+          </a:lnRef>
+          <a:fillRef idx="3">
+            <a:schemeClr val="accent1"/>
+          </a:fillRef>
+          <a:effectRef idx="2">
+            <a:schemeClr val="accent1"/>
+          </a:effectRef>
+          <a:fontRef idx="minor">
+            <a:schemeClr val="lt1"/>
+          </a:fontRef>
+        </p:style>
+        <p:txBody>
+          <a:bodyPr rtlCol="0" anchor="ctr"/>
+          <a:lstStyle/>
+          <a:p>
+            <a:pPr algn="ctr"/>
+          </a:p>
+        </p:txBody>
+      </p:sp>
+      <p:sp>
+        <p:nvSpPr>
+          <p:cNvPr id="4" name="TextBox 3"/>
+          <p:cNvSpPr txBox="1"/>
+          <p:nvPr/>
+        </p:nvSpPr>
+        <p:spPr>
+          <a:xfrm>
+            <a:off x="457200" y="164592"/>
+            <a:ext cx="2743200" cy="457200"/>
+          </a:xfrm>
+          <a:prstGeom prst="rect">
+            <a:avLst/>
+          </a:prstGeom>
+          <a:noFill/>
+        </p:spPr>
+        <p:txBody>
+          <a:bodyPr wrap="square">
+            <a:spAutoFit/>
+          </a:bodyPr>
+          <a:lstStyle/>
+          <a:p>
+            <a:pPr algn="l"/>
+            <a:r>
+              <a:rPr sz="1200" b="1" i="0">
+                <a:solidFill>
+                  <a:srgbClr val="38BDF8"/>
+                </a:solidFill>
+              </a:rPr>
+              <a:t>STEP 04</a:t>
+            </a:r>
+          </a:p>
+        </p:txBody>
+      </p:sp>
+      <p:sp>
+        <p:nvSpPr>
+          <p:cNvPr id="5" name="TextBox 4"/>
+          <p:cNvSpPr txBox="1"/>
+          <p:nvPr/>
+        </p:nvSpPr>
+        <p:spPr>
+          <a:xfrm>
+            <a:off x="457200" y="502920"/>
+            <a:ext cx="10972800" cy="685800"/>
+          </a:xfrm>
+          <a:prstGeom prst="rect">
+            <a:avLst/>
+          </a:prstGeom>
+          <a:noFill/>
+        </p:spPr>
+        <p:txBody>
+          <a:bodyPr wrap="square">
+            <a:spAutoFit/>
+          </a:bodyPr>
+          <a:lstStyle/>
+          <a:p>
+            <a:pPr algn="l"/>
+            <a:r>
+              <a:rPr sz="2600" b="1" i="0">
+                <a:solidFill>
+                  <a:srgbClr val="FFFFFF"/>
+                </a:solidFill>
+              </a:rPr>
+              <a:t>API 코드 예제 — Python</a:t>
+            </a:r>
+          </a:p>
+        </p:txBody>
+      </p:sp>
+      <p:sp>
+        <p:nvSpPr>
+          <p:cNvPr id="6" name="TextBox 5"/>
+          <p:cNvSpPr txBox="1"/>
+          <p:nvPr/>
+        </p:nvSpPr>
+        <p:spPr>
+          <a:xfrm>
+            <a:off x="457200" y="1078992"/>
+            <a:ext cx="10972800" cy="411480"/>
+          </a:xfrm>
+          <a:prstGeom prst="rect">
+            <a:avLst/>
+          </a:prstGeom>
+          <a:noFill/>
+        </p:spPr>
+        <p:txBody>
+          <a:bodyPr wrap="square">
+            <a:spAutoFit/>
+          </a:bodyPr>
+          <a:lstStyle/>
+          <a:p>
+            <a:pPr algn="l"/>
+            <a:r>
+              <a:rPr sz="1300" b="0" i="1">
+                <a:solidFill>
+                  <a:srgbClr val="60A5FA"/>
+                </a:solidFill>
+              </a:rPr>
+              <a:t>① Device 등록  →  ② 대화방 생성  →  ③ 메시지 전송 순서로 호출합니다</a:t>
+            </a:r>
+          </a:p>
+        </p:txBody>
+      </p:sp>
+      <p:sp>
+        <p:nvSpPr>
+          <p:cNvPr id="7" name="Rectangle 6"/>
+          <p:cNvSpPr/>
+          <p:nvPr/>
+        </p:nvSpPr>
+        <p:spPr>
+          <a:xfrm>
+            <a:off x="365760" y="1371600"/>
+            <a:ext cx="11457432" cy="19050"/>
+          </a:xfrm>
+          <a:prstGeom prst="rect">
+            <a:avLst/>
+          </a:prstGeom>
+          <a:solidFill>
+            <a:srgbClr val="38BDF8"/>
+          </a:solidFill>
+          <a:ln>
+            <a:noFill/>
+          </a:ln>
+        </p:spPr>
+        <p:style>
+          <a:lnRef idx="1">
+            <a:schemeClr val="accent1"/>
+          </a:lnRef>
+          <a:fillRef idx="3">
+            <a:schemeClr val="accent1"/>
+          </a:fillRef>
+          <a:effectRef idx="2">
+            <a:schemeClr val="accent1"/>
+          </a:effectRef>
+          <a:fontRef idx="minor">
+            <a:schemeClr val="lt1"/>
+          </a:fontRef>
+        </p:style>
+        <p:txBody>
+          <a:bodyPr rtlCol="0" anchor="ctr"/>
+          <a:lstStyle/>
+          <a:p>
+            <a:pPr algn="ctr"/>
+          </a:p>
+        </p:txBody>
+      </p:sp>
+      <p:sp>
+        <p:nvSpPr>
+          <p:cNvPr id="8" name="Rectangle 7"/>
+          <p:cNvSpPr/>
+          <p:nvPr/>
+        </p:nvSpPr>
+        <p:spPr>
+          <a:xfrm>
+            <a:off x="365760" y="1508760"/>
+            <a:ext cx="5577840" cy="292608"/>
+          </a:xfrm>
+          <a:prstGeom prst="rect">
+            <a:avLst/>
+          </a:prstGeom>
+          <a:solidFill>
+            <a:srgbClr val="2D5A9E"/>
+          </a:solidFill>
+          <a:ln>
+            <a:noFill/>
+          </a:ln>
+        </p:spPr>
+        <p:style>
+          <a:lnRef idx="1">
+            <a:schemeClr val="accent1"/>
+          </a:lnRef>
+          <a:fillRef idx="3">
+            <a:schemeClr val="accent1"/>
+          </a:fillRef>
+          <a:effectRef idx="2">
+            <a:schemeClr val="accent1"/>
+          </a:effectRef>
+          <a:fontRef idx="minor">
+            <a:schemeClr val="lt1"/>
+          </a:fontRef>
+        </p:style>
+        <p:txBody>
+          <a:bodyPr rtlCol="0" anchor="ctr"/>
+          <a:lstStyle/>
+          <a:p>
+            <a:pPr algn="ctr"/>
+          </a:p>
+        </p:txBody>
+      </p:sp>
+      <p:sp>
+        <p:nvSpPr>
+          <p:cNvPr id="9" name="TextBox 8"/>
+          <p:cNvSpPr txBox="1"/>
+          <p:nvPr/>
+        </p:nvSpPr>
+        <p:spPr>
+          <a:xfrm>
+            <a:off x="365760" y="1508760"/>
+            <a:ext cx="5577840" cy="292608"/>
+          </a:xfrm>
+          <a:prstGeom prst="rect">
+            <a:avLst/>
+          </a:prstGeom>
+          <a:noFill/>
+        </p:spPr>
+        <p:txBody>
+          <a:bodyPr wrap="square">
+            <a:spAutoFit/>
+          </a:bodyPr>
+          <a:lstStyle/>
+          <a:p>
+            <a:pPr algn="l"/>
+            <a:r>
+              <a:rPr sz="1100" b="1" i="0">
+                <a:solidFill>
+                  <a:srgbClr val="FFFFFF"/>
+                </a:solidFill>
+              </a:rPr>
+              <a:t>  공통 설정 (Base URL &amp; Headers)</a:t>
+            </a:r>
+          </a:p>
+        </p:txBody>
+      </p:sp>
+      <p:sp>
+        <p:nvSpPr>
+          <p:cNvPr id="10" name="Rectangle 9"/>
+          <p:cNvSpPr/>
+          <p:nvPr/>
+        </p:nvSpPr>
+        <p:spPr>
+          <a:xfrm>
+            <a:off x="365760" y="1801368"/>
+            <a:ext cx="5577840" cy="1508760"/>
+          </a:xfrm>
+          <a:prstGeom prst="rect">
+            <a:avLst/>
+          </a:prstGeom>
+          <a:solidFill>
+            <a:srgbClr val="1E293B"/>
+          </a:solidFill>
+          <a:ln>
+            <a:noFill/>
+          </a:ln>
+        </p:spPr>
+        <p:style>
+          <a:lnRef idx="1">
+            <a:schemeClr val="accent1"/>
+          </a:lnRef>
+          <a:fillRef idx="3">
+            <a:schemeClr val="accent1"/>
+          </a:fillRef>
+          <a:effectRef idx="2">
+            <a:schemeClr val="accent1"/>
+          </a:effectRef>
+          <a:fontRef idx="minor">
+            <a:schemeClr val="lt1"/>
+          </a:fontRef>
+        </p:style>
+        <p:txBody>
+          <a:bodyPr rtlCol="0" anchor="ctr"/>
+          <a:lstStyle/>
+          <a:p>
+            <a:pPr algn="ctr"/>
+          </a:p>
+        </p:txBody>
+      </p:sp>
+      <p:sp>
+        <p:nvSpPr>
+          <p:cNvPr id="11" name="Rectangle 10"/>
+          <p:cNvSpPr/>
+          <p:nvPr/>
+        </p:nvSpPr>
+        <p:spPr>
+          <a:xfrm>
+            <a:off x="365760" y="1801368"/>
+            <a:ext cx="45720" cy="1508760"/>
+          </a:xfrm>
+          <a:prstGeom prst="rect">
+            <a:avLst/>
+          </a:prstGeom>
+          <a:solidFill>
+            <a:srgbClr val="38BDF8"/>
+          </a:solidFill>
+          <a:ln>
+            <a:noFill/>
+          </a:ln>
+        </p:spPr>
+        <p:style>
+          <a:lnRef idx="1">
+            <a:schemeClr val="accent1"/>
+          </a:lnRef>
+          <a:fillRef idx="3">
+            <a:schemeClr val="accent1"/>
+          </a:fillRef>
+          <a:effectRef idx="2">
+            <a:schemeClr val="accent1"/>
+          </a:effectRef>
+          <a:fontRef idx="minor">
+            <a:schemeClr val="lt1"/>
+          </a:fontRef>
+        </p:style>
+        <p:txBody>
+          <a:bodyPr rtlCol="0" anchor="ctr"/>
+          <a:lstStyle/>
+          <a:p>
+            <a:pPr algn="ctr"/>
+          </a:p>
+        </p:txBody>
+      </p:sp>
+      <p:sp>
+        <p:nvSpPr>
+          <p:cNvPr id="12" name="TextBox 11"/>
+          <p:cNvSpPr txBox="1"/>
+          <p:nvPr/>
+        </p:nvSpPr>
+        <p:spPr>
+          <a:xfrm>
+            <a:off x="475488" y="1847088"/>
+            <a:ext cx="5413248" cy="1435608"/>
+          </a:xfrm>
+          <a:prstGeom prst="rect">
+            <a:avLst/>
+          </a:prstGeom>
+          <a:noFill/>
+        </p:spPr>
+        <p:txBody>
+          <a:bodyPr wrap="square">
+            <a:spAutoFit/>
+          </a:bodyPr>
+          <a:lstStyle/>
+          <a:p>
+            <a:pPr algn="l"/>
+            <a:r>
+              <a:rPr sz="950" b="0" i="0">
+                <a:solidFill>
+                  <a:srgbClr val="93C5FD"/>
+                </a:solidFill>
+              </a:rPr>
+              <a:t>import requests
+BASE = "https://openapi.stage.samsung.net"
+headers = {
+    "Authorization": "Bearer &lt;ACCESS_TOKEN&gt;",
+    "x-system-id":   "&lt;SYSTEM_ID&gt;",
+    "Content-Type":  "application/json",
+}</a:t>
+            </a:r>
+          </a:p>
+        </p:txBody>
+      </p:sp>
+      <p:sp>
+        <p:nvSpPr>
+          <p:cNvPr id="13" name="Rectangle 12"/>
+          <p:cNvSpPr/>
+          <p:nvPr/>
+        </p:nvSpPr>
+        <p:spPr>
+          <a:xfrm>
+            <a:off x="365760" y="3401568"/>
+            <a:ext cx="5577840" cy="292608"/>
+          </a:xfrm>
+          <a:prstGeom prst="rect">
+            <a:avLst/>
+          </a:prstGeom>
+          <a:solidFill>
+            <a:srgbClr val="1E3A6E"/>
+          </a:solidFill>
+          <a:ln>
+            <a:noFill/>
+          </a:ln>
+        </p:spPr>
+        <p:style>
+          <a:lnRef idx="1">
+            <a:schemeClr val="accent1"/>
+          </a:lnRef>
+          <a:fillRef idx="3">
+            <a:schemeClr val="accent1"/>
+          </a:fillRef>
+          <a:effectRef idx="2">
+            <a:schemeClr val="accent1"/>
+          </a:effectRef>
+          <a:fontRef idx="minor">
+            <a:schemeClr val="lt1"/>
+          </a:fontRef>
+        </p:style>
+        <p:txBody>
+          <a:bodyPr rtlCol="0" anchor="ctr"/>
+          <a:lstStyle/>
+          <a:p>
+            <a:pPr algn="ctr"/>
+          </a:p>
+        </p:txBody>
+      </p:sp>
+      <p:sp>
+        <p:nvSpPr>
+          <p:cNvPr id="14" name="TextBox 13"/>
+          <p:cNvSpPr txBox="1"/>
+          <p:nvPr/>
+        </p:nvSpPr>
+        <p:spPr>
+          <a:xfrm>
+            <a:off x="365760" y="3401568"/>
+            <a:ext cx="5577840" cy="292608"/>
+          </a:xfrm>
+          <a:prstGeom prst="rect">
+            <a:avLst/>
+          </a:prstGeom>
+          <a:noFill/>
+        </p:spPr>
+        <p:txBody>
+          <a:bodyPr wrap="square">
+            <a:spAutoFit/>
+          </a:bodyPr>
+          <a:lstStyle/>
+          <a:p>
+            <a:pPr algn="l"/>
+            <a:r>
+              <a:rPr sz="1100" b="1" i="0">
+                <a:solidFill>
+                  <a:srgbClr val="FFFFFF"/>
+                </a:solidFill>
+              </a:rPr>
+              <a:t>  ① Device 등록</a:t>
+            </a:r>
+          </a:p>
+        </p:txBody>
+      </p:sp>
+      <p:sp>
+        <p:nvSpPr>
+          <p:cNvPr id="15" name="Rectangle 14"/>
+          <p:cNvSpPr/>
+          <p:nvPr/>
+        </p:nvSpPr>
+        <p:spPr>
+          <a:xfrm>
+            <a:off x="365760" y="3694176"/>
+            <a:ext cx="5577840" cy="1508760"/>
+          </a:xfrm>
+          <a:prstGeom prst="rect">
+            <a:avLst/>
+          </a:prstGeom>
+          <a:solidFill>
+            <a:srgbClr val="1E293B"/>
+          </a:solidFill>
+          <a:ln>
+            <a:noFill/>
+          </a:ln>
+        </p:spPr>
+        <p:style>
+          <a:lnRef idx="1">
+            <a:schemeClr val="accent1"/>
+          </a:lnRef>
+          <a:fillRef idx="3">
+            <a:schemeClr val="accent1"/>
+          </a:fillRef>
+          <a:effectRef idx="2">
+            <a:schemeClr val="accent1"/>
+          </a:effectRef>
+          <a:fontRef idx="minor">
+            <a:schemeClr val="lt1"/>
+          </a:fontRef>
+        </p:style>
+        <p:txBody>
+          <a:bodyPr rtlCol="0" anchor="ctr"/>
+          <a:lstStyle/>
+          <a:p>
+            <a:pPr algn="ctr"/>
+          </a:p>
+        </p:txBody>
+      </p:sp>
+      <p:sp>
+        <p:nvSpPr>
+          <p:cNvPr id="16" name="Rectangle 15"/>
+          <p:cNvSpPr/>
+          <p:nvPr/>
+        </p:nvSpPr>
+        <p:spPr>
+          <a:xfrm>
+            <a:off x="365760" y="3694176"/>
+            <a:ext cx="45720" cy="1508760"/>
+          </a:xfrm>
+          <a:prstGeom prst="rect">
+            <a:avLst/>
+          </a:prstGeom>
+          <a:solidFill>
+            <a:srgbClr val="38BDF8"/>
+          </a:solidFill>
+          <a:ln>
+            <a:noFill/>
+          </a:ln>
+        </p:spPr>
+        <p:style>
+          <a:lnRef idx="1">
+            <a:schemeClr val="accent1"/>
+          </a:lnRef>
+          <a:fillRef idx="3">
+            <a:schemeClr val="accent1"/>
+          </a:fillRef>
+          <a:effectRef idx="2">
+            <a:schemeClr val="accent1"/>
+          </a:effectRef>
+          <a:fontRef idx="minor">
+            <a:schemeClr val="lt1"/>
+          </a:fontRef>
+        </p:style>
+        <p:txBody>
+          <a:bodyPr rtlCol="0" anchor="ctr"/>
+          <a:lstStyle/>
+          <a:p>
+            <a:pPr algn="ctr"/>
+          </a:p>
+        </p:txBody>
+      </p:sp>
+      <p:sp>
+        <p:nvSpPr>
+          <p:cNvPr id="17" name="TextBox 16"/>
+          <p:cNvSpPr txBox="1"/>
+          <p:nvPr/>
+        </p:nvSpPr>
+        <p:spPr>
+          <a:xfrm>
+            <a:off x="475488" y="3739896"/>
+            <a:ext cx="5413248" cy="1435608"/>
+          </a:xfrm>
+          <a:prstGeom prst="rect">
+            <a:avLst/>
+          </a:prstGeom>
+          <a:noFill/>
+        </p:spPr>
+        <p:txBody>
+          <a:bodyPr wrap="square">
+            <a:spAutoFit/>
+          </a:bodyPr>
+          <a:lstStyle/>
+          <a:p>
+            <a:pPr algn="l"/>
+            <a:r>
+              <a:rPr sz="950" b="0" i="0">
+                <a:solidFill>
+                  <a:srgbClr val="93C5FD"/>
+                </a:solidFill>
+              </a:rPr>
+              <a:t>res = requests.post(
+    f"{BASE}/messenger/bot/v1/device",
+    headers=headers,
+    json={"deviceName": "fa-service-bot"},
+)
+device_id = res.json()["deviceId"]
+# device_id 를 저장해 두세요</a:t>
+            </a:r>
+          </a:p>
+        </p:txBody>
+      </p:sp>
+      <p:sp>
+        <p:nvSpPr>
+          <p:cNvPr id="18" name="Rectangle 17"/>
+          <p:cNvSpPr/>
+          <p:nvPr/>
+        </p:nvSpPr>
+        <p:spPr>
+          <a:xfrm>
+            <a:off x="365760" y="5047488"/>
+            <a:ext cx="5577840" cy="457200"/>
+          </a:xfrm>
+          <a:prstGeom prst="rect">
+            <a:avLst/>
+          </a:prstGeom>
+          <a:solidFill>
+            <a:srgbClr val="1E293B"/>
+          </a:solidFill>
+          <a:ln>
+            <a:noFill/>
+          </a:ln>
+        </p:spPr>
+        <p:style>
+          <a:lnRef idx="1">
+            <a:schemeClr val="accent1"/>
+          </a:lnRef>
+          <a:fillRef idx="3">
+            <a:schemeClr val="accent1"/>
+          </a:fillRef>
+          <a:effectRef idx="2">
+            <a:schemeClr val="accent1"/>
+          </a:effectRef>
+          <a:fontRef idx="minor">
+            <a:schemeClr val="lt1"/>
+          </a:fontRef>
+        </p:style>
+        <p:txBody>
+          <a:bodyPr rtlCol="0" anchor="ctr"/>
+          <a:lstStyle/>
+          <a:p>
+            <a:pPr algn="ctr"/>
+          </a:p>
+        </p:txBody>
+      </p:sp>
+      <p:sp>
+        <p:nvSpPr>
+          <p:cNvPr id="19" name="Rectangle 18"/>
+          <p:cNvSpPr/>
+          <p:nvPr/>
+        </p:nvSpPr>
+        <p:spPr>
+          <a:xfrm>
+            <a:off x="365760" y="5047488"/>
+            <a:ext cx="54864" cy="457200"/>
+          </a:xfrm>
+          <a:prstGeom prst="rect">
+            <a:avLst/>
+          </a:prstGeom>
+          <a:solidFill>
+            <a:srgbClr val="10B981"/>
+          </a:solidFill>
+          <a:ln>
+            <a:noFill/>
+          </a:ln>
+        </p:spPr>
+        <p:style>
+          <a:lnRef idx="1">
+            <a:schemeClr val="accent1"/>
+          </a:lnRef>
+          <a:fillRef idx="3">
+            <a:schemeClr val="accent1"/>
+          </a:fillRef>
+          <a:effectRef idx="2">
+            <a:schemeClr val="accent1"/>
+          </a:effectRef>
+          <a:fontRef idx="minor">
+            <a:schemeClr val="lt1"/>
+          </a:fontRef>
+        </p:style>
+        <p:txBody>
+          <a:bodyPr rtlCol="0" anchor="ctr"/>
+          <a:lstStyle/>
+          <a:p>
+            <a:pPr algn="ctr"/>
+          </a:p>
+        </p:txBody>
+      </p:sp>
+      <p:sp>
+        <p:nvSpPr>
+          <p:cNvPr id="20" name="TextBox 19"/>
+          <p:cNvSpPr txBox="1"/>
+          <p:nvPr/>
+        </p:nvSpPr>
+        <p:spPr>
+          <a:xfrm>
+            <a:off x="502920" y="5102352"/>
+            <a:ext cx="5394960" cy="365760"/>
+          </a:xfrm>
+          <a:prstGeom prst="rect">
+            <a:avLst/>
+          </a:prstGeom>
+          <a:noFill/>
+        </p:spPr>
+        <p:txBody>
+          <a:bodyPr wrap="square">
+            <a:spAutoFit/>
+          </a:bodyPr>
+          <a:lstStyle/>
+          <a:p>
+            <a:pPr algn="l"/>
+            <a:r>
+              <a:rPr sz="1100" b="0" i="0">
+                <a:solidFill>
+                  <a:srgbClr val="FFFFFF"/>
+                </a:solidFill>
+              </a:rPr>
+              <a:t>💡 device_id : 이후 모든 API 호출에  x-device-id  헤더로 사용합니다</a:t>
+            </a:r>
+          </a:p>
+        </p:txBody>
+      </p:sp>
+      <p:sp>
+        <p:nvSpPr>
+          <p:cNvPr id="21" name="Rectangle 20"/>
+          <p:cNvSpPr/>
+          <p:nvPr/>
+        </p:nvSpPr>
+        <p:spPr>
+          <a:xfrm>
+            <a:off x="365760" y="5596128"/>
+            <a:ext cx="5577840" cy="457200"/>
+          </a:xfrm>
+          <a:prstGeom prst="rect">
+            <a:avLst/>
+          </a:prstGeom>
+          <a:solidFill>
+            <a:srgbClr val="1E293B"/>
+          </a:solidFill>
+          <a:ln>
+            <a:noFill/>
+          </a:ln>
+        </p:spPr>
+        <p:style>
+          <a:lnRef idx="1">
+            <a:schemeClr val="accent1"/>
+          </a:lnRef>
+          <a:fillRef idx="3">
+            <a:schemeClr val="accent1"/>
+          </a:fillRef>
+          <a:effectRef idx="2">
+            <a:schemeClr val="accent1"/>
+          </a:effectRef>
+          <a:fontRef idx="minor">
+            <a:schemeClr val="lt1"/>
+          </a:fontRef>
+        </p:style>
+        <p:txBody>
+          <a:bodyPr rtlCol="0" anchor="ctr"/>
+          <a:lstStyle/>
+          <a:p>
+            <a:pPr algn="ctr"/>
+          </a:p>
+        </p:txBody>
+      </p:sp>
+      <p:sp>
+        <p:nvSpPr>
+          <p:cNvPr id="22" name="Rectangle 21"/>
+          <p:cNvSpPr/>
+          <p:nvPr/>
+        </p:nvSpPr>
+        <p:spPr>
+          <a:xfrm>
+            <a:off x="365760" y="5596128"/>
+            <a:ext cx="54864" cy="457200"/>
+          </a:xfrm>
+          <a:prstGeom prst="rect">
+            <a:avLst/>
+          </a:prstGeom>
+          <a:solidFill>
+            <a:srgbClr val="64748B"/>
+          </a:solidFill>
+          <a:ln>
+            <a:noFill/>
+          </a:ln>
+        </p:spPr>
+        <p:style>
+          <a:lnRef idx="1">
+            <a:schemeClr val="accent1"/>
+          </a:lnRef>
+          <a:fillRef idx="3">
+            <a:schemeClr val="accent1"/>
+          </a:fillRef>
+          <a:effectRef idx="2">
+            <a:schemeClr val="accent1"/>
+          </a:effectRef>
+          <a:fontRef idx="minor">
+            <a:schemeClr val="lt1"/>
+          </a:fontRef>
+        </p:style>
+        <p:txBody>
+          <a:bodyPr rtlCol="0" anchor="ctr"/>
+          <a:lstStyle/>
+          <a:p>
+            <a:pPr algn="ctr"/>
+          </a:p>
+        </p:txBody>
+      </p:sp>
+      <p:sp>
+        <p:nvSpPr>
+          <p:cNvPr id="23" name="TextBox 22"/>
+          <p:cNvSpPr txBox="1"/>
+          <p:nvPr/>
+        </p:nvSpPr>
+        <p:spPr>
+          <a:xfrm>
+            <a:off x="502920" y="5650992"/>
+            <a:ext cx="5394960" cy="365760"/>
+          </a:xfrm>
+          <a:prstGeom prst="rect">
+            <a:avLst/>
+          </a:prstGeom>
+          <a:noFill/>
+        </p:spPr>
+        <p:txBody>
+          <a:bodyPr wrap="square">
+            <a:spAutoFit/>
+          </a:bodyPr>
+          <a:lstStyle/>
+          <a:p>
+            <a:pPr algn="l"/>
+            <a:r>
+              <a:rPr sz="1100" b="0" i="0">
+                <a:solidFill>
+                  <a:srgbClr val="FFFFFF"/>
+                </a:solidFill>
+              </a:rPr>
+              <a:t>📌 운영 서버:  BASE = "https://openapi.samsung.net"  으로 변경</a:t>
+            </a:r>
+          </a:p>
+        </p:txBody>
+      </p:sp>
+      <p:sp>
+        <p:nvSpPr>
+          <p:cNvPr id="24" name="Rectangle 23"/>
+          <p:cNvSpPr/>
+          <p:nvPr/>
+        </p:nvSpPr>
+        <p:spPr>
+          <a:xfrm>
+            <a:off x="6336792" y="1508760"/>
+            <a:ext cx="5577840" cy="292608"/>
+          </a:xfrm>
+          <a:prstGeom prst="rect">
+            <a:avLst/>
+          </a:prstGeom>
+          <a:solidFill>
+            <a:srgbClr val="1E3A6E"/>
+          </a:solidFill>
+          <a:ln>
+            <a:noFill/>
+          </a:ln>
+        </p:spPr>
+        <p:style>
+          <a:lnRef idx="1">
+            <a:schemeClr val="accent1"/>
+          </a:lnRef>
+          <a:fillRef idx="3">
+            <a:schemeClr val="accent1"/>
+          </a:fillRef>
+          <a:effectRef idx="2">
+            <a:schemeClr val="accent1"/>
+          </a:effectRef>
+          <a:fontRef idx="minor">
+            <a:schemeClr val="lt1"/>
+          </a:fontRef>
+        </p:style>
+        <p:txBody>
+          <a:bodyPr rtlCol="0" anchor="ctr"/>
+          <a:lstStyle/>
+          <a:p>
+            <a:pPr algn="ctr"/>
+          </a:p>
+        </p:txBody>
+      </p:sp>
+      <p:sp>
+        <p:nvSpPr>
+          <p:cNvPr id="25" name="TextBox 24"/>
+          <p:cNvSpPr txBox="1"/>
+          <p:nvPr/>
+        </p:nvSpPr>
+        <p:spPr>
+          <a:xfrm>
+            <a:off x="6336792" y="1508760"/>
+            <a:ext cx="5577840" cy="292608"/>
+          </a:xfrm>
+          <a:prstGeom prst="rect">
+            <a:avLst/>
+          </a:prstGeom>
+          <a:noFill/>
+        </p:spPr>
+        <p:txBody>
+          <a:bodyPr wrap="square">
+            <a:spAutoFit/>
+          </a:bodyPr>
+          <a:lstStyle/>
+          <a:p>
+            <a:pPr algn="l"/>
+            <a:r>
+              <a:rPr sz="1100" b="1" i="0">
+                <a:solidFill>
+                  <a:srgbClr val="FFFFFF"/>
+                </a:solidFill>
+              </a:rPr>
+              <a:t>  ② 대화방 생성</a:t>
+            </a:r>
+          </a:p>
+        </p:txBody>
+      </p:sp>
+      <p:sp>
+        <p:nvSpPr>
+          <p:cNvPr id="26" name="Rectangle 25"/>
+          <p:cNvSpPr/>
+          <p:nvPr/>
+        </p:nvSpPr>
+        <p:spPr>
+          <a:xfrm>
+            <a:off x="6336792" y="1801368"/>
+            <a:ext cx="5577840" cy="1874519"/>
+          </a:xfrm>
+          <a:prstGeom prst="rect">
+            <a:avLst/>
+          </a:prstGeom>
+          <a:solidFill>
+            <a:srgbClr val="1E293B"/>
+          </a:solidFill>
+          <a:ln>
+            <a:noFill/>
+          </a:ln>
+        </p:spPr>
+        <p:style>
+          <a:lnRef idx="1">
+            <a:schemeClr val="accent1"/>
+          </a:lnRef>
+          <a:fillRef idx="3">
+            <a:schemeClr val="accent1"/>
+          </a:fillRef>
+          <a:effectRef idx="2">
+            <a:schemeClr val="accent1"/>
+          </a:effectRef>
+          <a:fontRef idx="minor">
+            <a:schemeClr val="lt1"/>
+          </a:fontRef>
+        </p:style>
+        <p:txBody>
+          <a:bodyPr rtlCol="0" anchor="ctr"/>
+          <a:lstStyle/>
+          <a:p>
+            <a:pPr algn="ctr"/>
+          </a:p>
+        </p:txBody>
+      </p:sp>
+      <p:sp>
+        <p:nvSpPr>
+          <p:cNvPr id="27" name="Rectangle 26"/>
+          <p:cNvSpPr/>
+          <p:nvPr/>
+        </p:nvSpPr>
+        <p:spPr>
+          <a:xfrm>
+            <a:off x="6336792" y="1801368"/>
+            <a:ext cx="45720" cy="1874519"/>
+          </a:xfrm>
+          <a:prstGeom prst="rect">
+            <a:avLst/>
+          </a:prstGeom>
+          <a:solidFill>
+            <a:srgbClr val="38BDF8"/>
+          </a:solidFill>
+          <a:ln>
+            <a:noFill/>
+          </a:ln>
+        </p:spPr>
+        <p:style>
+          <a:lnRef idx="1">
+            <a:schemeClr val="accent1"/>
+          </a:lnRef>
+          <a:fillRef idx="3">
+            <a:schemeClr val="accent1"/>
+          </a:fillRef>
+          <a:effectRef idx="2">
+            <a:schemeClr val="accent1"/>
+          </a:effectRef>
+          <a:fontRef idx="minor">
+            <a:schemeClr val="lt1"/>
+          </a:fontRef>
+        </p:style>
+        <p:txBody>
+          <a:bodyPr rtlCol="0" anchor="ctr"/>
+          <a:lstStyle/>
+          <a:p>
+            <a:pPr algn="ctr"/>
+          </a:p>
+        </p:txBody>
+      </p:sp>
+      <p:sp>
+        <p:nvSpPr>
+          <p:cNvPr id="28" name="TextBox 27"/>
+          <p:cNvSpPr txBox="1"/>
+          <p:nvPr/>
+        </p:nvSpPr>
+        <p:spPr>
+          <a:xfrm>
+            <a:off x="6446520" y="1847088"/>
+            <a:ext cx="5413248" cy="1801367"/>
+          </a:xfrm>
+          <a:prstGeom prst="rect">
+            <a:avLst/>
+          </a:prstGeom>
+          <a:noFill/>
+        </p:spPr>
+        <p:txBody>
+          <a:bodyPr wrap="square">
+            <a:spAutoFit/>
+          </a:bodyPr>
+          <a:lstStyle/>
+          <a:p>
+            <a:pPr algn="l"/>
+            <a:r>
+              <a:rPr sz="950" b="0" i="0">
+                <a:solidFill>
+                  <a:srgbClr val="93C5FD"/>
+                </a:solidFill>
+              </a:rPr>
+              <a:t>res = requests.post(
+    f"{BASE}/messenger/bot/v1/chatroom",
+    headers={**headers, "x-device-id": device_id},
+    json={
+        "roomName": "FA 분석 알림",
+        "memberList": ["hong.gildong@samsung.com"],
+    },
+)
+room_id = res.json()["roomId"]</a:t>
+            </a:r>
+          </a:p>
+        </p:txBody>
+      </p:sp>
+      <p:sp>
+        <p:nvSpPr>
+          <p:cNvPr id="29" name="Rectangle 28"/>
+          <p:cNvSpPr/>
+          <p:nvPr/>
+        </p:nvSpPr>
+        <p:spPr>
+          <a:xfrm>
+            <a:off x="6336792" y="3493008"/>
+            <a:ext cx="5577840" cy="292608"/>
+          </a:xfrm>
+          <a:prstGeom prst="rect">
+            <a:avLst/>
+          </a:prstGeom>
+          <a:solidFill>
+            <a:srgbClr val="2D5A9E"/>
+          </a:solidFill>
+          <a:ln>
+            <a:noFill/>
+          </a:ln>
+        </p:spPr>
+        <p:style>
+          <a:lnRef idx="1">
+            <a:schemeClr val="accent1"/>
+          </a:lnRef>
+          <a:fillRef idx="3">
+            <a:schemeClr val="accent1"/>
+          </a:fillRef>
+          <a:effectRef idx="2">
+            <a:schemeClr val="accent1"/>
+          </a:effectRef>
+          <a:fontRef idx="minor">
+            <a:schemeClr val="lt1"/>
+          </a:fontRef>
+        </p:style>
+        <p:txBody>
+          <a:bodyPr rtlCol="0" anchor="ctr"/>
+          <a:lstStyle/>
+          <a:p>
+            <a:pPr algn="ctr"/>
+          </a:p>
+        </p:txBody>
+      </p:sp>
+      <p:sp>
+        <p:nvSpPr>
+          <p:cNvPr id="30" name="TextBox 29"/>
+          <p:cNvSpPr txBox="1"/>
+          <p:nvPr/>
+        </p:nvSpPr>
+        <p:spPr>
+          <a:xfrm>
+            <a:off x="6336792" y="3493008"/>
+            <a:ext cx="5577840" cy="292608"/>
+          </a:xfrm>
+          <a:prstGeom prst="rect">
+            <a:avLst/>
+          </a:prstGeom>
+          <a:noFill/>
+        </p:spPr>
+        <p:txBody>
+          <a:bodyPr wrap="square">
+            <a:spAutoFit/>
+          </a:bodyPr>
+          <a:lstStyle/>
+          <a:p>
+            <a:pPr algn="l"/>
+            <a:r>
+              <a:rPr sz="1100" b="1" i="0">
+                <a:solidFill>
+                  <a:srgbClr val="FFFFFF"/>
+                </a:solidFill>
+              </a:rPr>
+              <a:t>  ③ 메시지 전송</a:t>
+            </a:r>
+          </a:p>
+        </p:txBody>
+      </p:sp>
+      <p:sp>
+        <p:nvSpPr>
+          <p:cNvPr id="31" name="Rectangle 30"/>
+          <p:cNvSpPr/>
+          <p:nvPr/>
+        </p:nvSpPr>
+        <p:spPr>
+          <a:xfrm>
+            <a:off x="6336792" y="3785616"/>
+            <a:ext cx="5577840" cy="1874519"/>
+          </a:xfrm>
+          <a:prstGeom prst="rect">
+            <a:avLst/>
+          </a:prstGeom>
+          <a:solidFill>
+            <a:srgbClr val="1E293B"/>
+          </a:solidFill>
+          <a:ln>
+            <a:noFill/>
+          </a:ln>
+        </p:spPr>
+        <p:style>
+          <a:lnRef idx="1">
+            <a:schemeClr val="accent1"/>
+          </a:lnRef>
+          <a:fillRef idx="3">
+            <a:schemeClr val="accent1"/>
+          </a:fillRef>
+          <a:effectRef idx="2">
+            <a:schemeClr val="accent1"/>
+          </a:effectRef>
+          <a:fontRef idx="minor">
+            <a:schemeClr val="lt1"/>
+          </a:fontRef>
+        </p:style>
+        <p:txBody>
+          <a:bodyPr rtlCol="0" anchor="ctr"/>
+          <a:lstStyle/>
+          <a:p>
+            <a:pPr algn="ctr"/>
+          </a:p>
+        </p:txBody>
+      </p:sp>
+      <p:sp>
+        <p:nvSpPr>
+          <p:cNvPr id="32" name="Rectangle 31"/>
+          <p:cNvSpPr/>
+          <p:nvPr/>
+        </p:nvSpPr>
+        <p:spPr>
+          <a:xfrm>
+            <a:off x="6336792" y="3785616"/>
+            <a:ext cx="45720" cy="1874519"/>
+          </a:xfrm>
+          <a:prstGeom prst="rect">
+            <a:avLst/>
+          </a:prstGeom>
+          <a:solidFill>
+            <a:srgbClr val="38BDF8"/>
+          </a:solidFill>
+          <a:ln>
+            <a:noFill/>
+          </a:ln>
+        </p:spPr>
+        <p:style>
+          <a:lnRef idx="1">
+            <a:schemeClr val="accent1"/>
+          </a:lnRef>
+          <a:fillRef idx="3">
+            <a:schemeClr val="accent1"/>
+          </a:fillRef>
+          <a:effectRef idx="2">
+            <a:schemeClr val="accent1"/>
+          </a:effectRef>
+          <a:fontRef idx="minor">
+            <a:schemeClr val="lt1"/>
+          </a:fontRef>
+        </p:style>
+        <p:txBody>
+          <a:bodyPr rtlCol="0" anchor="ctr"/>
+          <a:lstStyle/>
+          <a:p>
+            <a:pPr algn="ctr"/>
+          </a:p>
+        </p:txBody>
+      </p:sp>
+      <p:sp>
+        <p:nvSpPr>
+          <p:cNvPr id="33" name="TextBox 32"/>
+          <p:cNvSpPr txBox="1"/>
+          <p:nvPr/>
+        </p:nvSpPr>
+        <p:spPr>
+          <a:xfrm>
+            <a:off x="6446520" y="3831336"/>
+            <a:ext cx="5413248" cy="1801367"/>
+          </a:xfrm>
+          <a:prstGeom prst="rect">
+            <a:avLst/>
+          </a:prstGeom>
+          <a:noFill/>
+        </p:spPr>
+        <p:txBody>
+          <a:bodyPr wrap="square">
+            <a:spAutoFit/>
+          </a:bodyPr>
+          <a:lstStyle/>
+          <a:p>
+            <a:pPr algn="l"/>
+            <a:r>
+              <a:rPr sz="950" b="0" i="0">
+                <a:solidFill>
+                  <a:srgbClr val="93C5FD"/>
+                </a:solidFill>
+              </a:rPr>
+              <a:t>res = requests.post(
+    f"{BASE}/messenger/bot/v1/message",
+    headers={**headers, "x-device-id": device_id},
+    json={
+        "roomId": room_id,
+        "messageType": "TEXT",
+        "message": "FA 분석이 완료되었습니다.",
+    },
+)
+# 응답: {"result": "success", ...}</a:t>
+            </a:r>
+          </a:p>
+        </p:txBody>
+      </p:sp>
+      <p:sp>
+        <p:nvSpPr>
+          <p:cNvPr id="34" name="Rectangle 33"/>
+          <p:cNvSpPr/>
+          <p:nvPr/>
+        </p:nvSpPr>
+        <p:spPr>
+          <a:xfrm>
+            <a:off x="6336792" y="5486400"/>
+            <a:ext cx="5577840" cy="457200"/>
+          </a:xfrm>
+          <a:prstGeom prst="rect">
+            <a:avLst/>
+          </a:prstGeom>
+          <a:solidFill>
+            <a:srgbClr val="1E293B"/>
+          </a:solidFill>
+          <a:ln>
+            <a:noFill/>
+          </a:ln>
+        </p:spPr>
+        <p:style>
+          <a:lnRef idx="1">
+            <a:schemeClr val="accent1"/>
+          </a:lnRef>
+          <a:fillRef idx="3">
+            <a:schemeClr val="accent1"/>
+          </a:fillRef>
+          <a:effectRef idx="2">
+            <a:schemeClr val="accent1"/>
+          </a:effectRef>
+          <a:fontRef idx="minor">
+            <a:schemeClr val="lt1"/>
+          </a:fontRef>
+        </p:style>
+        <p:txBody>
+          <a:bodyPr rtlCol="0" anchor="ctr"/>
+          <a:lstStyle/>
+          <a:p>
+            <a:pPr algn="ctr"/>
+          </a:p>
+        </p:txBody>
+      </p:sp>
+      <p:sp>
+        <p:nvSpPr>
+          <p:cNvPr id="35" name="Rectangle 34"/>
+          <p:cNvSpPr/>
+          <p:nvPr/>
+        </p:nvSpPr>
+        <p:spPr>
+          <a:xfrm>
+            <a:off x="6336792" y="5486400"/>
+            <a:ext cx="54864" cy="457200"/>
+          </a:xfrm>
+          <a:prstGeom prst="rect">
+            <a:avLst/>
+          </a:prstGeom>
+          <a:solidFill>
+            <a:srgbClr val="38BDF8"/>
+          </a:solidFill>
+          <a:ln>
+            <a:noFill/>
+          </a:ln>
+        </p:spPr>
+        <p:style>
+          <a:lnRef idx="1">
+            <a:schemeClr val="accent1"/>
+          </a:lnRef>
+          <a:fillRef idx="3">
+            <a:schemeClr val="accent1"/>
+          </a:fillRef>
+          <a:effectRef idx="2">
+            <a:schemeClr val="accent1"/>
+          </a:effectRef>
+          <a:fontRef idx="minor">
+            <a:schemeClr val="lt1"/>
+          </a:fontRef>
+        </p:style>
+        <p:txBody>
+          <a:bodyPr rtlCol="0" anchor="ctr"/>
+          <a:lstStyle/>
+          <a:p>
+            <a:pPr algn="ctr"/>
+          </a:p>
+        </p:txBody>
+      </p:sp>
+      <p:sp>
+        <p:nvSpPr>
+          <p:cNvPr id="36" name="TextBox 35"/>
+          <p:cNvSpPr txBox="1"/>
+          <p:nvPr/>
+        </p:nvSpPr>
+        <p:spPr>
+          <a:xfrm>
+            <a:off x="6473952" y="5541264"/>
+            <a:ext cx="5394960" cy="365760"/>
+          </a:xfrm>
+          <a:prstGeom prst="rect">
+            <a:avLst/>
+          </a:prstGeom>
+          <a:noFill/>
+        </p:spPr>
+        <p:txBody>
+          <a:bodyPr wrap="square">
+            <a:spAutoFit/>
+          </a:bodyPr>
+          <a:lstStyle/>
+          <a:p>
+            <a:pPr algn="l"/>
+            <a:r>
+              <a:rPr sz="1100" b="0" i="0">
+                <a:solidFill>
+                  <a:srgbClr val="FFFFFF"/>
+                </a:solidFill>
+              </a:rPr>
+              <a:t>💡 실제 엔드포인트/파라미터는 Knox Developer Center 공식 문서를 반드시 확인하세요</a:t>
+            </a:r>
+          </a:p>
+        </p:txBody>
+      </p:sp>
+    </p:spTree>
+  </p:cSld>
+  <p:clrMapOvr>
+    <a:masterClrMapping/>
+  </p:clrMapOvr>
+</p:sld>
+</file>
+
+<file path=ppt/slides/slide9.xml><?xml version="1.0" encoding="utf-8"?>
 <p:sld xmlns:a="http://schemas.openxmlformats.org/drawingml/2006/main" xmlns:p="http://schemas.openxmlformats.org/presentationml/2006/main" xmlns:r="http://schemas.openxmlformats.org/officeDocument/2006/relationships">
   <p:cSld>
     <p:spTree>

</xml_diff>

<commit_message>
Adaptive Card & PDF 파일 전송 API 예제 슬라이드 추가
- Adaptive Card 발신: messageType=CARD, cardTitle/cardContent/cardButtonList 구조
- PDF 파일 전송: POST /file 로 업로드 → fileId 획득 → messageType=FILE 로 전송
- 각 섹션 하단에 활용 팁(버튼 종류, 줄바꿈, 파일 크기 제한 등) 안내

https://claude.ai/code/session_01T97wq5dgMtUQadeWGjzCmF
</commit_message>
<xml_diff>
--- a/knox_chatbot_가이드.pptx
+++ b/knox_chatbot_가이드.pptx
@@ -14,6 +14,7 @@
     <p:sldId id="262" r:id="rId13"/>
     <p:sldId id="263" r:id="rId14"/>
     <p:sldId id="264" r:id="rId15"/>
+    <p:sldId id="265" r:id="rId16"/>
   </p:sldIdLst>
   <p:sldSz cx="12188952" cy="6858000" type="screen4x3"/>
   <p:notesSz cx="6858000" cy="9144000"/>
@@ -3447,6 +3448,951 @@
 </p:sld>
 </file>
 
+<file path=ppt/slides/slide10.xml><?xml version="1.0" encoding="utf-8"?>
+<p:sld xmlns:a="http://schemas.openxmlformats.org/drawingml/2006/main" xmlns:p="http://schemas.openxmlformats.org/presentationml/2006/main" xmlns:r="http://schemas.openxmlformats.org/officeDocument/2006/relationships">
+  <p:cSld>
+    <p:spTree>
+      <p:nvGrpSpPr>
+        <p:cNvPr id="1" name=""/>
+        <p:cNvGrpSpPr/>
+        <p:nvPr/>
+      </p:nvGrpSpPr>
+      <p:grpSpPr/>
+      <p:sp>
+        <p:nvSpPr>
+          <p:cNvPr id="2" name="Rectangle 1"/>
+          <p:cNvSpPr/>
+          <p:nvPr/>
+        </p:nvSpPr>
+        <p:spPr>
+          <a:xfrm>
+            <a:off x="0" y="0"/>
+            <a:ext cx="12188952" cy="6858000"/>
+          </a:xfrm>
+          <a:prstGeom prst="rect">
+            <a:avLst/>
+          </a:prstGeom>
+          <a:solidFill>
+            <a:srgbClr val="0F172A"/>
+          </a:solidFill>
+          <a:ln>
+            <a:noFill/>
+          </a:ln>
+        </p:spPr>
+        <p:style>
+          <a:lnRef idx="1">
+            <a:schemeClr val="accent1"/>
+          </a:lnRef>
+          <a:fillRef idx="3">
+            <a:schemeClr val="accent1"/>
+          </a:fillRef>
+          <a:effectRef idx="2">
+            <a:schemeClr val="accent1"/>
+          </a:effectRef>
+          <a:fontRef idx="minor">
+            <a:schemeClr val="lt1"/>
+          </a:fontRef>
+        </p:style>
+        <p:txBody>
+          <a:bodyPr rtlCol="0" anchor="ctr"/>
+          <a:lstStyle/>
+          <a:p>
+            <a:pPr algn="ctr"/>
+          </a:p>
+        </p:txBody>
+      </p:sp>
+      <p:sp>
+        <p:nvSpPr>
+          <p:cNvPr id="3" name="Rectangle 2"/>
+          <p:cNvSpPr/>
+          <p:nvPr/>
+        </p:nvSpPr>
+        <p:spPr>
+          <a:xfrm>
+            <a:off x="0" y="0"/>
+            <a:ext cx="12188952" cy="91440"/>
+          </a:xfrm>
+          <a:prstGeom prst="rect">
+            <a:avLst/>
+          </a:prstGeom>
+          <a:solidFill>
+            <a:srgbClr val="38BDF8"/>
+          </a:solidFill>
+          <a:ln>
+            <a:noFill/>
+          </a:ln>
+        </p:spPr>
+        <p:style>
+          <a:lnRef idx="1">
+            <a:schemeClr val="accent1"/>
+          </a:lnRef>
+          <a:fillRef idx="3">
+            <a:schemeClr val="accent1"/>
+          </a:fillRef>
+          <a:effectRef idx="2">
+            <a:schemeClr val="accent1"/>
+          </a:effectRef>
+          <a:fontRef idx="minor">
+            <a:schemeClr val="lt1"/>
+          </a:fontRef>
+        </p:style>
+        <p:txBody>
+          <a:bodyPr rtlCol="0" anchor="ctr"/>
+          <a:lstStyle/>
+          <a:p>
+            <a:pPr algn="ctr"/>
+          </a:p>
+        </p:txBody>
+      </p:sp>
+      <p:sp>
+        <p:nvSpPr>
+          <p:cNvPr id="4" name="TextBox 3"/>
+          <p:cNvSpPr txBox="1"/>
+          <p:nvPr/>
+        </p:nvSpPr>
+        <p:spPr>
+          <a:xfrm>
+            <a:off x="457200" y="164592"/>
+            <a:ext cx="2743200" cy="457200"/>
+          </a:xfrm>
+          <a:prstGeom prst="rect">
+            <a:avLst/>
+          </a:prstGeom>
+          <a:noFill/>
+        </p:spPr>
+        <p:txBody>
+          <a:bodyPr wrap="square">
+            <a:spAutoFit/>
+          </a:bodyPr>
+          <a:lstStyle/>
+          <a:p>
+            <a:pPr algn="l"/>
+            <a:r>
+              <a:rPr sz="1200" b="1" i="0">
+                <a:solidFill>
+                  <a:srgbClr val="38BDF8"/>
+                </a:solidFill>
+              </a:rPr>
+              <a:t>STEP 05</a:t>
+            </a:r>
+          </a:p>
+        </p:txBody>
+      </p:sp>
+      <p:sp>
+        <p:nvSpPr>
+          <p:cNvPr id="5" name="TextBox 4"/>
+          <p:cNvSpPr txBox="1"/>
+          <p:nvPr/>
+        </p:nvSpPr>
+        <p:spPr>
+          <a:xfrm>
+            <a:off x="457200" y="502920"/>
+            <a:ext cx="10972800" cy="685800"/>
+          </a:xfrm>
+          <a:prstGeom prst="rect">
+            <a:avLst/>
+          </a:prstGeom>
+          <a:noFill/>
+        </p:spPr>
+        <p:txBody>
+          <a:bodyPr wrap="square">
+            <a:spAutoFit/>
+          </a:bodyPr>
+          <a:lstStyle/>
+          <a:p>
+            <a:pPr algn="l"/>
+            <a:r>
+              <a:rPr sz="2600" b="1" i="0">
+                <a:solidFill>
+                  <a:srgbClr val="FFFFFF"/>
+                </a:solidFill>
+              </a:rPr>
+              <a:t>FAQ</a:t>
+            </a:r>
+          </a:p>
+        </p:txBody>
+      </p:sp>
+      <p:sp>
+        <p:nvSpPr>
+          <p:cNvPr id="6" name="TextBox 5"/>
+          <p:cNvSpPr txBox="1"/>
+          <p:nvPr/>
+        </p:nvSpPr>
+        <p:spPr>
+          <a:xfrm>
+            <a:off x="457200" y="1078992"/>
+            <a:ext cx="10972800" cy="411480"/>
+          </a:xfrm>
+          <a:prstGeom prst="rect">
+            <a:avLst/>
+          </a:prstGeom>
+          <a:noFill/>
+        </p:spPr>
+        <p:txBody>
+          <a:bodyPr wrap="square">
+            <a:spAutoFit/>
+          </a:bodyPr>
+          <a:lstStyle/>
+          <a:p>
+            <a:pPr algn="l"/>
+            <a:r>
+              <a:rPr sz="1300" b="0" i="1">
+                <a:solidFill>
+                  <a:srgbClr val="60A5FA"/>
+                </a:solidFill>
+              </a:rPr>
+              <a:t>궁금한 점이 있을 때 참고하세요</a:t>
+            </a:r>
+          </a:p>
+        </p:txBody>
+      </p:sp>
+      <p:sp>
+        <p:nvSpPr>
+          <p:cNvPr id="7" name="Rectangle 6"/>
+          <p:cNvSpPr/>
+          <p:nvPr/>
+        </p:nvSpPr>
+        <p:spPr>
+          <a:xfrm>
+            <a:off x="365760" y="1371600"/>
+            <a:ext cx="11457432" cy="19050"/>
+          </a:xfrm>
+          <a:prstGeom prst="rect">
+            <a:avLst/>
+          </a:prstGeom>
+          <a:solidFill>
+            <a:srgbClr val="38BDF8"/>
+          </a:solidFill>
+          <a:ln>
+            <a:noFill/>
+          </a:ln>
+        </p:spPr>
+        <p:style>
+          <a:lnRef idx="1">
+            <a:schemeClr val="accent1"/>
+          </a:lnRef>
+          <a:fillRef idx="3">
+            <a:schemeClr val="accent1"/>
+          </a:fillRef>
+          <a:effectRef idx="2">
+            <a:schemeClr val="accent1"/>
+          </a:effectRef>
+          <a:fontRef idx="minor">
+            <a:schemeClr val="lt1"/>
+          </a:fontRef>
+        </p:style>
+        <p:txBody>
+          <a:bodyPr rtlCol="0" anchor="ctr"/>
+          <a:lstStyle/>
+          <a:p>
+            <a:pPr algn="ctr"/>
+          </a:p>
+        </p:txBody>
+      </p:sp>
+      <p:sp>
+        <p:nvSpPr>
+          <p:cNvPr id="8" name="Rectangle 7"/>
+          <p:cNvSpPr/>
+          <p:nvPr/>
+        </p:nvSpPr>
+        <p:spPr>
+          <a:xfrm>
+            <a:off x="365760" y="1600200"/>
+            <a:ext cx="5669280" cy="1417320"/>
+          </a:xfrm>
+          <a:prstGeom prst="rect">
+            <a:avLst/>
+          </a:prstGeom>
+          <a:solidFill>
+            <a:srgbClr val="1E3A6E"/>
+          </a:solidFill>
+          <a:ln>
+            <a:noFill/>
+          </a:ln>
+        </p:spPr>
+        <p:style>
+          <a:lnRef idx="1">
+            <a:schemeClr val="accent1"/>
+          </a:lnRef>
+          <a:fillRef idx="3">
+            <a:schemeClr val="accent1"/>
+          </a:fillRef>
+          <a:effectRef idx="2">
+            <a:schemeClr val="accent1"/>
+          </a:effectRef>
+          <a:fontRef idx="minor">
+            <a:schemeClr val="lt1"/>
+          </a:fontRef>
+        </p:style>
+        <p:txBody>
+          <a:bodyPr rtlCol="0" anchor="ctr"/>
+          <a:lstStyle/>
+          <a:p>
+            <a:pPr algn="ctr"/>
+          </a:p>
+        </p:txBody>
+      </p:sp>
+      <p:sp>
+        <p:nvSpPr>
+          <p:cNvPr id="9" name="Rectangle 8"/>
+          <p:cNvSpPr/>
+          <p:nvPr/>
+        </p:nvSpPr>
+        <p:spPr>
+          <a:xfrm>
+            <a:off x="365760" y="1600200"/>
+            <a:ext cx="5669280" cy="73152"/>
+          </a:xfrm>
+          <a:prstGeom prst="rect">
+            <a:avLst/>
+          </a:prstGeom>
+          <a:solidFill>
+            <a:srgbClr val="38BDF8"/>
+          </a:solidFill>
+          <a:ln>
+            <a:noFill/>
+          </a:ln>
+        </p:spPr>
+        <p:style>
+          <a:lnRef idx="1">
+            <a:schemeClr val="accent1"/>
+          </a:lnRef>
+          <a:fillRef idx="3">
+            <a:schemeClr val="accent1"/>
+          </a:fillRef>
+          <a:effectRef idx="2">
+            <a:schemeClr val="accent1"/>
+          </a:effectRef>
+          <a:fontRef idx="minor">
+            <a:schemeClr val="lt1"/>
+          </a:fontRef>
+        </p:style>
+        <p:txBody>
+          <a:bodyPr rtlCol="0" anchor="ctr"/>
+          <a:lstStyle/>
+          <a:p>
+            <a:pPr algn="ctr"/>
+          </a:p>
+        </p:txBody>
+      </p:sp>
+      <p:sp>
+        <p:nvSpPr>
+          <p:cNvPr id="10" name="Rectangle 9"/>
+          <p:cNvSpPr/>
+          <p:nvPr/>
+        </p:nvSpPr>
+        <p:spPr>
+          <a:xfrm>
+            <a:off x="365760" y="1709928"/>
+            <a:ext cx="548640" cy="502920"/>
+          </a:xfrm>
+          <a:prstGeom prst="rect">
+            <a:avLst/>
+          </a:prstGeom>
+          <a:solidFill>
+            <a:srgbClr val="2D5A9E"/>
+          </a:solidFill>
+          <a:ln>
+            <a:noFill/>
+          </a:ln>
+        </p:spPr>
+        <p:style>
+          <a:lnRef idx="1">
+            <a:schemeClr val="accent1"/>
+          </a:lnRef>
+          <a:fillRef idx="3">
+            <a:schemeClr val="accent1"/>
+          </a:fillRef>
+          <a:effectRef idx="2">
+            <a:schemeClr val="accent1"/>
+          </a:effectRef>
+          <a:fontRef idx="minor">
+            <a:schemeClr val="lt1"/>
+          </a:fontRef>
+        </p:style>
+        <p:txBody>
+          <a:bodyPr rtlCol="0" anchor="ctr"/>
+          <a:lstStyle/>
+          <a:p>
+            <a:pPr algn="ctr"/>
+          </a:p>
+        </p:txBody>
+      </p:sp>
+      <p:sp>
+        <p:nvSpPr>
+          <p:cNvPr id="11" name="TextBox 10"/>
+          <p:cNvSpPr txBox="1"/>
+          <p:nvPr/>
+        </p:nvSpPr>
+        <p:spPr>
+          <a:xfrm>
+            <a:off x="365760" y="1709928"/>
+            <a:ext cx="548640" cy="475488"/>
+          </a:xfrm>
+          <a:prstGeom prst="rect">
+            <a:avLst/>
+          </a:prstGeom>
+          <a:noFill/>
+        </p:spPr>
+        <p:txBody>
+          <a:bodyPr wrap="square">
+            <a:spAutoFit/>
+          </a:bodyPr>
+          <a:lstStyle/>
+          <a:p>
+            <a:pPr algn="ctr"/>
+            <a:r>
+              <a:rPr sz="1300" b="1" i="0">
+                <a:solidFill>
+                  <a:srgbClr val="38BDF8"/>
+                </a:solidFill>
+              </a:rPr>
+              <a:t>Q1</a:t>
+            </a:r>
+          </a:p>
+        </p:txBody>
+      </p:sp>
+      <p:sp>
+        <p:nvSpPr>
+          <p:cNvPr id="12" name="TextBox 11"/>
+          <p:cNvSpPr txBox="1"/>
+          <p:nvPr/>
+        </p:nvSpPr>
+        <p:spPr>
+          <a:xfrm>
+            <a:off x="1005840" y="1709928"/>
+            <a:ext cx="4983480" cy="475488"/>
+          </a:xfrm>
+          <a:prstGeom prst="rect">
+            <a:avLst/>
+          </a:prstGeom>
+          <a:noFill/>
+        </p:spPr>
+        <p:txBody>
+          <a:bodyPr wrap="square">
+            <a:spAutoFit/>
+          </a:bodyPr>
+          <a:lstStyle/>
+          <a:p>
+            <a:pPr algn="l"/>
+            <a:r>
+              <a:rPr sz="1400" b="1" i="0">
+                <a:solidFill>
+                  <a:srgbClr val="FFFFFF"/>
+                </a:solidFill>
+              </a:rPr>
+              <a:t>문의는 어디에 하나요?</a:t>
+            </a:r>
+          </a:p>
+        </p:txBody>
+      </p:sp>
+      <p:sp>
+        <p:nvSpPr>
+          <p:cNvPr id="13" name="TextBox 12"/>
+          <p:cNvSpPr txBox="1"/>
+          <p:nvPr/>
+        </p:nvSpPr>
+        <p:spPr>
+          <a:xfrm>
+            <a:off x="1005840" y="2240280"/>
+            <a:ext cx="4983480" cy="685800"/>
+          </a:xfrm>
+          <a:prstGeom prst="rect">
+            <a:avLst/>
+          </a:prstGeom>
+          <a:noFill/>
+        </p:spPr>
+        <p:txBody>
+          <a:bodyPr wrap="square">
+            <a:spAutoFit/>
+          </a:bodyPr>
+          <a:lstStyle/>
+          <a:p>
+            <a:pPr algn="l"/>
+            <a:r>
+              <a:rPr sz="1200" b="0" i="0">
+                <a:solidFill>
+                  <a:srgbClr val="60A5FA"/>
+                </a:solidFill>
+              </a:rPr>
+              <a:t>Knoxportal@samsung.com 으로 이메일 문의</a:t>
+            </a:r>
+          </a:p>
+        </p:txBody>
+      </p:sp>
+      <p:sp>
+        <p:nvSpPr>
+          <p:cNvPr id="14" name="Rectangle 13"/>
+          <p:cNvSpPr/>
+          <p:nvPr/>
+        </p:nvSpPr>
+        <p:spPr>
+          <a:xfrm>
+            <a:off x="365760" y="3246120"/>
+            <a:ext cx="5669280" cy="1417320"/>
+          </a:xfrm>
+          <a:prstGeom prst="rect">
+            <a:avLst/>
+          </a:prstGeom>
+          <a:solidFill>
+            <a:srgbClr val="1E3A6E"/>
+          </a:solidFill>
+          <a:ln>
+            <a:noFill/>
+          </a:ln>
+        </p:spPr>
+        <p:style>
+          <a:lnRef idx="1">
+            <a:schemeClr val="accent1"/>
+          </a:lnRef>
+          <a:fillRef idx="3">
+            <a:schemeClr val="accent1"/>
+          </a:fillRef>
+          <a:effectRef idx="2">
+            <a:schemeClr val="accent1"/>
+          </a:effectRef>
+          <a:fontRef idx="minor">
+            <a:schemeClr val="lt1"/>
+          </a:fontRef>
+        </p:style>
+        <p:txBody>
+          <a:bodyPr rtlCol="0" anchor="ctr"/>
+          <a:lstStyle/>
+          <a:p>
+            <a:pPr algn="ctr"/>
+          </a:p>
+        </p:txBody>
+      </p:sp>
+      <p:sp>
+        <p:nvSpPr>
+          <p:cNvPr id="15" name="Rectangle 14"/>
+          <p:cNvSpPr/>
+          <p:nvPr/>
+        </p:nvSpPr>
+        <p:spPr>
+          <a:xfrm>
+            <a:off x="365760" y="3246120"/>
+            <a:ext cx="5669280" cy="73152"/>
+          </a:xfrm>
+          <a:prstGeom prst="rect">
+            <a:avLst/>
+          </a:prstGeom>
+          <a:solidFill>
+            <a:srgbClr val="38BDF8"/>
+          </a:solidFill>
+          <a:ln>
+            <a:noFill/>
+          </a:ln>
+        </p:spPr>
+        <p:style>
+          <a:lnRef idx="1">
+            <a:schemeClr val="accent1"/>
+          </a:lnRef>
+          <a:fillRef idx="3">
+            <a:schemeClr val="accent1"/>
+          </a:fillRef>
+          <a:effectRef idx="2">
+            <a:schemeClr val="accent1"/>
+          </a:effectRef>
+          <a:fontRef idx="minor">
+            <a:schemeClr val="lt1"/>
+          </a:fontRef>
+        </p:style>
+        <p:txBody>
+          <a:bodyPr rtlCol="0" anchor="ctr"/>
+          <a:lstStyle/>
+          <a:p>
+            <a:pPr algn="ctr"/>
+          </a:p>
+        </p:txBody>
+      </p:sp>
+      <p:sp>
+        <p:nvSpPr>
+          <p:cNvPr id="16" name="Rectangle 15"/>
+          <p:cNvSpPr/>
+          <p:nvPr/>
+        </p:nvSpPr>
+        <p:spPr>
+          <a:xfrm>
+            <a:off x="365760" y="3355848"/>
+            <a:ext cx="548640" cy="502920"/>
+          </a:xfrm>
+          <a:prstGeom prst="rect">
+            <a:avLst/>
+          </a:prstGeom>
+          <a:solidFill>
+            <a:srgbClr val="2D5A9E"/>
+          </a:solidFill>
+          <a:ln>
+            <a:noFill/>
+          </a:ln>
+        </p:spPr>
+        <p:style>
+          <a:lnRef idx="1">
+            <a:schemeClr val="accent1"/>
+          </a:lnRef>
+          <a:fillRef idx="3">
+            <a:schemeClr val="accent1"/>
+          </a:fillRef>
+          <a:effectRef idx="2">
+            <a:schemeClr val="accent1"/>
+          </a:effectRef>
+          <a:fontRef idx="minor">
+            <a:schemeClr val="lt1"/>
+          </a:fontRef>
+        </p:style>
+        <p:txBody>
+          <a:bodyPr rtlCol="0" anchor="ctr"/>
+          <a:lstStyle/>
+          <a:p>
+            <a:pPr algn="ctr"/>
+          </a:p>
+        </p:txBody>
+      </p:sp>
+      <p:sp>
+        <p:nvSpPr>
+          <p:cNvPr id="17" name="TextBox 16"/>
+          <p:cNvSpPr txBox="1"/>
+          <p:nvPr/>
+        </p:nvSpPr>
+        <p:spPr>
+          <a:xfrm>
+            <a:off x="365760" y="3355848"/>
+            <a:ext cx="548640" cy="475488"/>
+          </a:xfrm>
+          <a:prstGeom prst="rect">
+            <a:avLst/>
+          </a:prstGeom>
+          <a:noFill/>
+        </p:spPr>
+        <p:txBody>
+          <a:bodyPr wrap="square">
+            <a:spAutoFit/>
+          </a:bodyPr>
+          <a:lstStyle/>
+          <a:p>
+            <a:pPr algn="ctr"/>
+            <a:r>
+              <a:rPr sz="1300" b="1" i="0">
+                <a:solidFill>
+                  <a:srgbClr val="38BDF8"/>
+                </a:solidFill>
+              </a:rPr>
+              <a:t>Q2</a:t>
+            </a:r>
+          </a:p>
+        </p:txBody>
+      </p:sp>
+      <p:sp>
+        <p:nvSpPr>
+          <p:cNvPr id="18" name="TextBox 17"/>
+          <p:cNvSpPr txBox="1"/>
+          <p:nvPr/>
+        </p:nvSpPr>
+        <p:spPr>
+          <a:xfrm>
+            <a:off x="1005840" y="3355848"/>
+            <a:ext cx="4983480" cy="475488"/>
+          </a:xfrm>
+          <a:prstGeom prst="rect">
+            <a:avLst/>
+          </a:prstGeom>
+          <a:noFill/>
+        </p:spPr>
+        <p:txBody>
+          <a:bodyPr wrap="square">
+            <a:spAutoFit/>
+          </a:bodyPr>
+          <a:lstStyle/>
+          <a:p>
+            <a:pPr algn="l"/>
+            <a:r>
+              <a:rPr sz="1400" b="1" i="0">
+                <a:solidFill>
+                  <a:srgbClr val="FFFFFF"/>
+                </a:solidFill>
+              </a:rPr>
+              <a:t>Knox Support는 어떻게 사용하나요?</a:t>
+            </a:r>
+          </a:p>
+        </p:txBody>
+      </p:sp>
+      <p:sp>
+        <p:nvSpPr>
+          <p:cNvPr id="19" name="TextBox 18"/>
+          <p:cNvSpPr txBox="1"/>
+          <p:nvPr/>
+        </p:nvSpPr>
+        <p:spPr>
+          <a:xfrm>
+            <a:off x="1005840" y="3886200"/>
+            <a:ext cx="4983480" cy="685800"/>
+          </a:xfrm>
+          <a:prstGeom prst="rect">
+            <a:avLst/>
+          </a:prstGeom>
+          <a:noFill/>
+        </p:spPr>
+        <p:txBody>
+          <a:bodyPr wrap="square">
+            <a:spAutoFit/>
+          </a:bodyPr>
+          <a:lstStyle/>
+          <a:p>
+            <a:pPr algn="l"/>
+            <a:r>
+              <a:rPr sz="1200" b="0" i="0">
+                <a:solidFill>
+                  <a:srgbClr val="60A5FA"/>
+                </a:solidFill>
+              </a:rPr>
+              <a:t>Knox Portal 화면 내 프로필 왼편  ❓  → Knox Support 진입
+Teams 메뉴에서 검색 및 문의 업로드 가능</a:t>
+            </a:r>
+          </a:p>
+        </p:txBody>
+      </p:sp>
+      <p:sp>
+        <p:nvSpPr>
+          <p:cNvPr id="20" name="Rectangle 19"/>
+          <p:cNvSpPr/>
+          <p:nvPr/>
+        </p:nvSpPr>
+        <p:spPr>
+          <a:xfrm>
+            <a:off x="6492240" y="1600200"/>
+            <a:ext cx="5394960" cy="4846320"/>
+          </a:xfrm>
+          <a:prstGeom prst="rect">
+            <a:avLst/>
+          </a:prstGeom>
+          <a:solidFill>
+            <a:srgbClr val="12223A"/>
+          </a:solidFill>
+          <a:ln w="19050">
+            <a:solidFill>
+              <a:srgbClr val="60A5FA"/>
+            </a:solidFill>
+          </a:ln>
+        </p:spPr>
+        <p:style>
+          <a:lnRef idx="1">
+            <a:schemeClr val="accent1"/>
+          </a:lnRef>
+          <a:fillRef idx="3">
+            <a:schemeClr val="accent1"/>
+          </a:fillRef>
+          <a:effectRef idx="2">
+            <a:schemeClr val="accent1"/>
+          </a:effectRef>
+          <a:fontRef idx="minor">
+            <a:schemeClr val="lt1"/>
+          </a:fontRef>
+        </p:style>
+        <p:txBody>
+          <a:bodyPr rtlCol="0" anchor="ctr"/>
+          <a:lstStyle/>
+          <a:p>
+            <a:pPr algn="ctr"/>
+          </a:p>
+        </p:txBody>
+      </p:sp>
+      <p:sp>
+        <p:nvSpPr>
+          <p:cNvPr id="21" name="TextBox 20"/>
+          <p:cNvSpPr txBox="1"/>
+          <p:nvPr/>
+        </p:nvSpPr>
+        <p:spPr>
+          <a:xfrm>
+            <a:off x="6492240" y="3703320"/>
+            <a:ext cx="5394960" cy="640080"/>
+          </a:xfrm>
+          <a:prstGeom prst="rect">
+            <a:avLst/>
+          </a:prstGeom>
+          <a:noFill/>
+        </p:spPr>
+        <p:txBody>
+          <a:bodyPr wrap="square">
+            <a:spAutoFit/>
+          </a:bodyPr>
+          <a:lstStyle/>
+          <a:p>
+            <a:pPr algn="ctr"/>
+            <a:r>
+              <a:rPr sz="1500" b="1" i="0">
+                <a:solidFill>
+                  <a:srgbClr val="60A5FA"/>
+                </a:solidFill>
+              </a:rPr>
+              <a:t>📷   Knox Support 화면 캡쳐</a:t>
+            </a:r>
+          </a:p>
+        </p:txBody>
+      </p:sp>
+      <p:sp>
+        <p:nvSpPr>
+          <p:cNvPr id="22" name="TextBox 21"/>
+          <p:cNvSpPr txBox="1"/>
+          <p:nvPr/>
+        </p:nvSpPr>
+        <p:spPr>
+          <a:xfrm>
+            <a:off x="457200" y="5029200"/>
+            <a:ext cx="5486400" cy="457200"/>
+          </a:xfrm>
+          <a:prstGeom prst="rect">
+            <a:avLst/>
+          </a:prstGeom>
+          <a:noFill/>
+        </p:spPr>
+        <p:txBody>
+          <a:bodyPr wrap="square">
+            <a:spAutoFit/>
+          </a:bodyPr>
+          <a:lstStyle/>
+          <a:p>
+            <a:pPr algn="l"/>
+            <a:r>
+              <a:rPr sz="1400" b="1" i="0">
+                <a:solidFill>
+                  <a:srgbClr val="38BDF8"/>
+                </a:solidFill>
+              </a:rPr>
+              <a:t>Knoxportal@samsung.com</a:t>
+            </a:r>
+          </a:p>
+        </p:txBody>
+      </p:sp>
+      <p:sp>
+        <p:nvSpPr>
+          <p:cNvPr id="23" name="Rectangle 22"/>
+          <p:cNvSpPr/>
+          <p:nvPr/>
+        </p:nvSpPr>
+        <p:spPr>
+          <a:xfrm>
+            <a:off x="365760" y="5577840"/>
+            <a:ext cx="5943600" cy="457200"/>
+          </a:xfrm>
+          <a:prstGeom prst="rect">
+            <a:avLst/>
+          </a:prstGeom>
+          <a:solidFill>
+            <a:srgbClr val="1E293B"/>
+          </a:solidFill>
+          <a:ln>
+            <a:noFill/>
+          </a:ln>
+        </p:spPr>
+        <p:style>
+          <a:lnRef idx="1">
+            <a:schemeClr val="accent1"/>
+          </a:lnRef>
+          <a:fillRef idx="3">
+            <a:schemeClr val="accent1"/>
+          </a:fillRef>
+          <a:effectRef idx="2">
+            <a:schemeClr val="accent1"/>
+          </a:effectRef>
+          <a:fontRef idx="minor">
+            <a:schemeClr val="lt1"/>
+          </a:fontRef>
+        </p:style>
+        <p:txBody>
+          <a:bodyPr rtlCol="0" anchor="ctr"/>
+          <a:lstStyle/>
+          <a:p>
+            <a:pPr algn="ctr"/>
+          </a:p>
+        </p:txBody>
+      </p:sp>
+      <p:sp>
+        <p:nvSpPr>
+          <p:cNvPr id="24" name="Rectangle 23"/>
+          <p:cNvSpPr/>
+          <p:nvPr/>
+        </p:nvSpPr>
+        <p:spPr>
+          <a:xfrm>
+            <a:off x="365760" y="5577840"/>
+            <a:ext cx="54864" cy="457200"/>
+          </a:xfrm>
+          <a:prstGeom prst="rect">
+            <a:avLst/>
+          </a:prstGeom>
+          <a:solidFill>
+            <a:srgbClr val="60A5FA"/>
+          </a:solidFill>
+          <a:ln>
+            <a:noFill/>
+          </a:ln>
+        </p:spPr>
+        <p:style>
+          <a:lnRef idx="1">
+            <a:schemeClr val="accent1"/>
+          </a:lnRef>
+          <a:fillRef idx="3">
+            <a:schemeClr val="accent1"/>
+          </a:fillRef>
+          <a:effectRef idx="2">
+            <a:schemeClr val="accent1"/>
+          </a:effectRef>
+          <a:fontRef idx="minor">
+            <a:schemeClr val="lt1"/>
+          </a:fontRef>
+        </p:style>
+        <p:txBody>
+          <a:bodyPr rtlCol="0" anchor="ctr"/>
+          <a:lstStyle/>
+          <a:p>
+            <a:pPr algn="ctr"/>
+          </a:p>
+        </p:txBody>
+      </p:sp>
+      <p:sp>
+        <p:nvSpPr>
+          <p:cNvPr id="25" name="TextBox 24"/>
+          <p:cNvSpPr txBox="1"/>
+          <p:nvPr/>
+        </p:nvSpPr>
+        <p:spPr>
+          <a:xfrm>
+            <a:off x="502920" y="5632704"/>
+            <a:ext cx="5760720" cy="365760"/>
+          </a:xfrm>
+          <a:prstGeom prst="rect">
+            <a:avLst/>
+          </a:prstGeom>
+          <a:noFill/>
+        </p:spPr>
+        <p:txBody>
+          <a:bodyPr wrap="square">
+            <a:spAutoFit/>
+          </a:bodyPr>
+          <a:lstStyle/>
+          <a:p>
+            <a:pPr algn="l"/>
+            <a:r>
+              <a:rPr sz="1100" b="0" i="0">
+                <a:solidFill>
+                  <a:srgbClr val="FFFFFF"/>
+                </a:solidFill>
+              </a:rPr>
+              <a:t>💡 Knox Portal 내 물음표(?) 버튼 → Knox Support → Teams 메뉴</a:t>
+            </a:r>
+          </a:p>
+        </p:txBody>
+      </p:sp>
+    </p:spTree>
+  </p:cSld>
+  <p:clrMapOvr>
+    <a:masterClrMapping/>
+  </p:clrMapOvr>
+</p:sld>
+</file>
+
 <file path=ppt/slides/slide2.xml><?xml version="1.0" encoding="utf-8"?>
 <p:sld xmlns:a="http://schemas.openxmlformats.org/drawingml/2006/main" xmlns:p="http://schemas.openxmlformats.org/presentationml/2006/main" xmlns:r="http://schemas.openxmlformats.org/officeDocument/2006/relationships">
   <p:cSld>
@@ -13643,7 +14589,7 @@
                   <a:srgbClr val="38BDF8"/>
                 </a:solidFill>
               </a:rPr>
-              <a:t>STEP 05</a:t>
+              <a:t>STEP 04</a:t>
             </a:r>
           </a:p>
         </p:txBody>
@@ -13677,7 +14623,7 @@
                   <a:srgbClr val="FFFFFF"/>
                 </a:solidFill>
               </a:rPr>
-              <a:t>FAQ</a:t>
+              <a:t>Adaptive Card &amp; 파일 전송 예제</a:t>
             </a:r>
           </a:p>
         </p:txBody>
@@ -13711,7 +14657,7 @@
                   <a:srgbClr val="60A5FA"/>
                 </a:solidFill>
               </a:rPr>
-              <a:t>궁금한 점이 있을 때 참고하세요</a:t>
+              <a:t>카드 메시지로 링크 버튼을 포함한 알림을 보내고, PDF 파일도 직접 전송할 수 있습니다</a:t>
             </a:r>
           </a:p>
         </p:txBody>
@@ -13767,14 +14713,14 @@
         </p:nvSpPr>
         <p:spPr>
           <a:xfrm>
-            <a:off x="365760" y="1600200"/>
-            <a:ext cx="5669280" cy="1417320"/>
-          </a:xfrm>
-          <a:prstGeom prst="rect">
-            <a:avLst/>
-          </a:prstGeom>
-          <a:solidFill>
-            <a:srgbClr val="1E3A6E"/>
+            <a:off x="365760" y="1508760"/>
+            <a:ext cx="5577840" cy="292608"/>
+          </a:xfrm>
+          <a:prstGeom prst="rect">
+            <a:avLst/>
+          </a:prstGeom>
+          <a:solidFill>
+            <a:srgbClr val="14536E"/>
           </a:solidFill>
           <a:ln>
             <a:noFill/>
@@ -13804,20 +14750,54 @@
       </p:sp>
       <p:sp>
         <p:nvSpPr>
-          <p:cNvPr id="9" name="Rectangle 8"/>
+          <p:cNvPr id="9" name="TextBox 8"/>
+          <p:cNvSpPr txBox="1"/>
+          <p:nvPr/>
+        </p:nvSpPr>
+        <p:spPr>
+          <a:xfrm>
+            <a:off x="365760" y="1508760"/>
+            <a:ext cx="5577840" cy="292608"/>
+          </a:xfrm>
+          <a:prstGeom prst="rect">
+            <a:avLst/>
+          </a:prstGeom>
+          <a:noFill/>
+        </p:spPr>
+        <p:txBody>
+          <a:bodyPr wrap="square">
+            <a:spAutoFit/>
+          </a:bodyPr>
+          <a:lstStyle/>
+          <a:p>
+            <a:pPr algn="l"/>
+            <a:r>
+              <a:rPr sz="1100" b="1" i="0">
+                <a:solidFill>
+                  <a:srgbClr val="FFFFFF"/>
+                </a:solidFill>
+              </a:rPr>
+              <a:t>  📋  Adaptive Card 발신 (링크 버튼 포함)</a:t>
+            </a:r>
+          </a:p>
+        </p:txBody>
+      </p:sp>
+      <p:sp>
+        <p:nvSpPr>
+          <p:cNvPr id="10" name="Rectangle 9"/>
           <p:cNvSpPr/>
           <p:nvPr/>
         </p:nvSpPr>
         <p:spPr>
           <a:xfrm>
-            <a:off x="365760" y="1600200"/>
-            <a:ext cx="5669280" cy="73152"/>
-          </a:xfrm>
-          <a:prstGeom prst="rect">
-            <a:avLst/>
-          </a:prstGeom>
-          <a:solidFill>
-            <a:srgbClr val="38BDF8"/>
+            <a:off x="365760" y="1801368"/>
+            <a:ext cx="5577840" cy="2971800"/>
+          </a:xfrm>
+          <a:prstGeom prst="rect">
+            <a:avLst/>
+          </a:prstGeom>
+          <a:solidFill>
+            <a:srgbClr val="1E293B"/>
           </a:solidFill>
           <a:ln>
             <a:noFill/>
@@ -13847,20 +14827,20 @@
       </p:sp>
       <p:sp>
         <p:nvSpPr>
-          <p:cNvPr id="10" name="Rectangle 9"/>
+          <p:cNvPr id="11" name="Rectangle 10"/>
           <p:cNvSpPr/>
           <p:nvPr/>
         </p:nvSpPr>
         <p:spPr>
           <a:xfrm>
-            <a:off x="365760" y="1709928"/>
-            <a:ext cx="548640" cy="502920"/>
-          </a:xfrm>
-          <a:prstGeom prst="rect">
-            <a:avLst/>
-          </a:prstGeom>
-          <a:solidFill>
-            <a:srgbClr val="2D5A9E"/>
+            <a:off x="365760" y="1801368"/>
+            <a:ext cx="45720" cy="2971800"/>
+          </a:xfrm>
+          <a:prstGeom prst="rect">
+            <a:avLst/>
+          </a:prstGeom>
+          <a:solidFill>
+            <a:srgbClr val="38BDF8"/>
           </a:solidFill>
           <a:ln>
             <a:noFill/>
@@ -13890,48 +14870,14 @@
       </p:sp>
       <p:sp>
         <p:nvSpPr>
-          <p:cNvPr id="11" name="TextBox 10"/>
-          <p:cNvSpPr txBox="1"/>
-          <p:nvPr/>
-        </p:nvSpPr>
-        <p:spPr>
-          <a:xfrm>
-            <a:off x="365760" y="1709928"/>
-            <a:ext cx="548640" cy="475488"/>
-          </a:xfrm>
-          <a:prstGeom prst="rect">
-            <a:avLst/>
-          </a:prstGeom>
-          <a:noFill/>
-        </p:spPr>
-        <p:txBody>
-          <a:bodyPr wrap="square">
-            <a:spAutoFit/>
-          </a:bodyPr>
-          <a:lstStyle/>
-          <a:p>
-            <a:pPr algn="ctr"/>
-            <a:r>
-              <a:rPr sz="1300" b="1" i="0">
-                <a:solidFill>
-                  <a:srgbClr val="38BDF8"/>
-                </a:solidFill>
-              </a:rPr>
-              <a:t>Q1</a:t>
-            </a:r>
-          </a:p>
-        </p:txBody>
-      </p:sp>
-      <p:sp>
-        <p:nvSpPr>
           <p:cNvPr id="12" name="TextBox 11"/>
           <p:cNvSpPr txBox="1"/>
           <p:nvPr/>
         </p:nvSpPr>
         <p:spPr>
           <a:xfrm>
-            <a:off x="1005840" y="1709928"/>
-            <a:ext cx="4983480" cy="475488"/>
+            <a:off x="475488" y="1847088"/>
+            <a:ext cx="5413248" cy="2907792"/>
           </a:xfrm>
           <a:prstGeom prst="rect">
             <a:avLst/>
@@ -13946,66 +14892,48 @@
           <a:p>
             <a:pPr algn="l"/>
             <a:r>
-              <a:rPr sz="1400" b="1" i="0">
-                <a:solidFill>
-                  <a:srgbClr val="FFFFFF"/>
-                </a:solidFill>
-              </a:rPr>
-              <a:t>문의는 어디에 하나요?</a:t>
-            </a:r>
-          </a:p>
-        </p:txBody>
-      </p:sp>
-      <p:sp>
-        <p:nvSpPr>
-          <p:cNvPr id="13" name="TextBox 12"/>
-          <p:cNvSpPr txBox="1"/>
-          <p:nvPr/>
-        </p:nvSpPr>
-        <p:spPr>
-          <a:xfrm>
-            <a:off x="1005840" y="2240280"/>
-            <a:ext cx="4983480" cy="685800"/>
-          </a:xfrm>
-          <a:prstGeom prst="rect">
-            <a:avLst/>
-          </a:prstGeom>
-          <a:noFill/>
-        </p:spPr>
-        <p:txBody>
-          <a:bodyPr wrap="square">
-            <a:spAutoFit/>
-          </a:bodyPr>
-          <a:lstStyle/>
-          <a:p>
-            <a:pPr algn="l"/>
-            <a:r>
-              <a:rPr sz="1200" b="0" i="0">
-                <a:solidFill>
-                  <a:srgbClr val="60A5FA"/>
-                </a:solidFill>
-              </a:rPr>
-              <a:t>Knoxportal@samsung.com 으로 이메일 문의</a:t>
-            </a:r>
-          </a:p>
-        </p:txBody>
-      </p:sp>
-      <p:sp>
-        <p:nvSpPr>
-          <p:cNvPr id="14" name="Rectangle 13"/>
+              <a:rPr sz="950" b="0" i="0">
+                <a:solidFill>
+                  <a:srgbClr val="93C5FD"/>
+                </a:solidFill>
+              </a:rPr>
+              <a:t>res = requests.post(
+    f"{BASE}/messenger/bot/v1/message",
+    headers={**headers, "x-device-id": device_id},
+    json={
+        "roomId": room_id,
+        "messageType": "CARD",
+        "cardTitle": "FA 분석 결과",
+        "cardContent": "SN: R3CX1234...\n이상 항목: 3건",
+        "cardButtonList": [
+            {
+                "buttonType": "LINK",
+                "buttonText": "결과 보기",
+                "buttonValue": "http://10.246.9.74/result",
+            },
+        ],
+    },
+)</a:t>
+            </a:r>
+          </a:p>
+        </p:txBody>
+      </p:sp>
+      <p:sp>
+        <p:nvSpPr>
+          <p:cNvPr id="13" name="Rectangle 12"/>
           <p:cNvSpPr/>
           <p:nvPr/>
         </p:nvSpPr>
         <p:spPr>
           <a:xfrm>
-            <a:off x="365760" y="3246120"/>
-            <a:ext cx="5669280" cy="1417320"/>
-          </a:xfrm>
-          <a:prstGeom prst="rect">
-            <a:avLst/>
-          </a:prstGeom>
-          <a:solidFill>
-            <a:srgbClr val="1E3A6E"/>
+            <a:off x="365760" y="4892040"/>
+            <a:ext cx="5577840" cy="457200"/>
+          </a:xfrm>
+          <a:prstGeom prst="rect">
+            <a:avLst/>
+          </a:prstGeom>
+          <a:solidFill>
+            <a:srgbClr val="1E293B"/>
           </a:solidFill>
           <a:ln>
             <a:noFill/>
@@ -14035,20 +14963,20 @@
       </p:sp>
       <p:sp>
         <p:nvSpPr>
-          <p:cNvPr id="15" name="Rectangle 14"/>
+          <p:cNvPr id="14" name="Rectangle 13"/>
           <p:cNvSpPr/>
           <p:nvPr/>
         </p:nvSpPr>
         <p:spPr>
           <a:xfrm>
-            <a:off x="365760" y="3246120"/>
-            <a:ext cx="5669280" cy="73152"/>
-          </a:xfrm>
-          <a:prstGeom prst="rect">
-            <a:avLst/>
-          </a:prstGeom>
-          <a:solidFill>
-            <a:srgbClr val="38BDF8"/>
+            <a:off x="365760" y="4892040"/>
+            <a:ext cx="54864" cy="457200"/>
+          </a:xfrm>
+          <a:prstGeom prst="rect">
+            <a:avLst/>
+          </a:prstGeom>
+          <a:solidFill>
+            <a:srgbClr val="60A5FA"/>
           </a:solidFill>
           <a:ln>
             <a:noFill/>
@@ -14078,20 +15006,54 @@
       </p:sp>
       <p:sp>
         <p:nvSpPr>
+          <p:cNvPr id="15" name="TextBox 14"/>
+          <p:cNvSpPr txBox="1"/>
+          <p:nvPr/>
+        </p:nvSpPr>
+        <p:spPr>
+          <a:xfrm>
+            <a:off x="502920" y="4946904"/>
+            <a:ext cx="5394960" cy="365760"/>
+          </a:xfrm>
+          <a:prstGeom prst="rect">
+            <a:avLst/>
+          </a:prstGeom>
+          <a:noFill/>
+        </p:spPr>
+        <p:txBody>
+          <a:bodyPr wrap="square">
+            <a:spAutoFit/>
+          </a:bodyPr>
+          <a:lstStyle/>
+          <a:p>
+            <a:pPr algn="l"/>
+            <a:r>
+              <a:rPr sz="1100" b="0" i="0">
+                <a:solidFill>
+                  <a:srgbClr val="FFFFFF"/>
+                </a:solidFill>
+              </a:rPr>
+              <a:t>💡 cardButtonList 에 버튼 여러 개 추가 가능 (LINK / 전화 / 위치 등)</a:t>
+            </a:r>
+          </a:p>
+        </p:txBody>
+      </p:sp>
+      <p:sp>
+        <p:nvSpPr>
           <p:cNvPr id="16" name="Rectangle 15"/>
           <p:cNvSpPr/>
           <p:nvPr/>
         </p:nvSpPr>
         <p:spPr>
           <a:xfrm>
-            <a:off x="365760" y="3355848"/>
-            <a:ext cx="548640" cy="502920"/>
-          </a:xfrm>
-          <a:prstGeom prst="rect">
-            <a:avLst/>
-          </a:prstGeom>
-          <a:solidFill>
-            <a:srgbClr val="2D5A9E"/>
+            <a:off x="365760" y="5458968"/>
+            <a:ext cx="5577840" cy="457200"/>
+          </a:xfrm>
+          <a:prstGeom prst="rect">
+            <a:avLst/>
+          </a:prstGeom>
+          <a:solidFill>
+            <a:srgbClr val="1E293B"/>
           </a:solidFill>
           <a:ln>
             <a:noFill/>
@@ -14121,128 +15083,23 @@
       </p:sp>
       <p:sp>
         <p:nvSpPr>
-          <p:cNvPr id="17" name="TextBox 16"/>
-          <p:cNvSpPr txBox="1"/>
-          <p:nvPr/>
-        </p:nvSpPr>
-        <p:spPr>
-          <a:xfrm>
-            <a:off x="365760" y="3355848"/>
-            <a:ext cx="548640" cy="475488"/>
-          </a:xfrm>
-          <a:prstGeom prst="rect">
-            <a:avLst/>
-          </a:prstGeom>
-          <a:noFill/>
-        </p:spPr>
-        <p:txBody>
-          <a:bodyPr wrap="square">
-            <a:spAutoFit/>
-          </a:bodyPr>
-          <a:lstStyle/>
-          <a:p>
-            <a:pPr algn="ctr"/>
-            <a:r>
-              <a:rPr sz="1300" b="1" i="0">
-                <a:solidFill>
-                  <a:srgbClr val="38BDF8"/>
-                </a:solidFill>
-              </a:rPr>
-              <a:t>Q2</a:t>
-            </a:r>
-          </a:p>
-        </p:txBody>
-      </p:sp>
-      <p:sp>
-        <p:nvSpPr>
-          <p:cNvPr id="18" name="TextBox 17"/>
-          <p:cNvSpPr txBox="1"/>
-          <p:nvPr/>
-        </p:nvSpPr>
-        <p:spPr>
-          <a:xfrm>
-            <a:off x="1005840" y="3355848"/>
-            <a:ext cx="4983480" cy="475488"/>
-          </a:xfrm>
-          <a:prstGeom prst="rect">
-            <a:avLst/>
-          </a:prstGeom>
-          <a:noFill/>
-        </p:spPr>
-        <p:txBody>
-          <a:bodyPr wrap="square">
-            <a:spAutoFit/>
-          </a:bodyPr>
-          <a:lstStyle/>
-          <a:p>
-            <a:pPr algn="l"/>
-            <a:r>
-              <a:rPr sz="1400" b="1" i="0">
-                <a:solidFill>
-                  <a:srgbClr val="FFFFFF"/>
-                </a:solidFill>
-              </a:rPr>
-              <a:t>Knox Support는 어떻게 사용하나요?</a:t>
-            </a:r>
-          </a:p>
-        </p:txBody>
-      </p:sp>
-      <p:sp>
-        <p:nvSpPr>
-          <p:cNvPr id="19" name="TextBox 18"/>
-          <p:cNvSpPr txBox="1"/>
-          <p:nvPr/>
-        </p:nvSpPr>
-        <p:spPr>
-          <a:xfrm>
-            <a:off x="1005840" y="3886200"/>
-            <a:ext cx="4983480" cy="685800"/>
-          </a:xfrm>
-          <a:prstGeom prst="rect">
-            <a:avLst/>
-          </a:prstGeom>
-          <a:noFill/>
-        </p:spPr>
-        <p:txBody>
-          <a:bodyPr wrap="square">
-            <a:spAutoFit/>
-          </a:bodyPr>
-          <a:lstStyle/>
-          <a:p>
-            <a:pPr algn="l"/>
-            <a:r>
-              <a:rPr sz="1200" b="0" i="0">
-                <a:solidFill>
-                  <a:srgbClr val="60A5FA"/>
-                </a:solidFill>
-              </a:rPr>
-              <a:t>Knox Portal 화면 내 프로필 왼편  ❓  → Knox Support 진입
-Teams 메뉴에서 검색 및 문의 업로드 가능</a:t>
-            </a:r>
-          </a:p>
-        </p:txBody>
-      </p:sp>
-      <p:sp>
-        <p:nvSpPr>
-          <p:cNvPr id="20" name="Rectangle 19"/>
+          <p:cNvPr id="17" name="Rectangle 16"/>
           <p:cNvSpPr/>
           <p:nvPr/>
         </p:nvSpPr>
         <p:spPr>
           <a:xfrm>
-            <a:off x="6492240" y="1600200"/>
-            <a:ext cx="5394960" cy="4846320"/>
-          </a:xfrm>
-          <a:prstGeom prst="rect">
-            <a:avLst/>
-          </a:prstGeom>
-          <a:solidFill>
-            <a:srgbClr val="12223A"/>
-          </a:solidFill>
-          <a:ln w="19050">
-            <a:solidFill>
-              <a:srgbClr val="60A5FA"/>
-            </a:solidFill>
+            <a:off x="365760" y="5458968"/>
+            <a:ext cx="54864" cy="457200"/>
+          </a:xfrm>
+          <a:prstGeom prst="rect">
+            <a:avLst/>
+          </a:prstGeom>
+          <a:solidFill>
+            <a:srgbClr val="64748B"/>
+          </a:solidFill>
+          <a:ln>
+            <a:noFill/>
           </a:ln>
         </p:spPr>
         <p:style>
@@ -14269,48 +15126,14 @@
       </p:sp>
       <p:sp>
         <p:nvSpPr>
-          <p:cNvPr id="21" name="TextBox 20"/>
-          <p:cNvSpPr txBox="1"/>
-          <p:nvPr/>
-        </p:nvSpPr>
-        <p:spPr>
-          <a:xfrm>
-            <a:off x="6492240" y="3703320"/>
-            <a:ext cx="5394960" cy="640080"/>
-          </a:xfrm>
-          <a:prstGeom prst="rect">
-            <a:avLst/>
-          </a:prstGeom>
-          <a:noFill/>
-        </p:spPr>
-        <p:txBody>
-          <a:bodyPr wrap="square">
-            <a:spAutoFit/>
-          </a:bodyPr>
-          <a:lstStyle/>
-          <a:p>
-            <a:pPr algn="ctr"/>
-            <a:r>
-              <a:rPr sz="1500" b="1" i="0">
-                <a:solidFill>
-                  <a:srgbClr val="60A5FA"/>
-                </a:solidFill>
-              </a:rPr>
-              <a:t>📷   Knox Support 화면 캡쳐</a:t>
-            </a:r>
-          </a:p>
-        </p:txBody>
-      </p:sp>
-      <p:sp>
-        <p:nvSpPr>
-          <p:cNvPr id="22" name="TextBox 21"/>
-          <p:cNvSpPr txBox="1"/>
-          <p:nvPr/>
-        </p:nvSpPr>
-        <p:spPr>
-          <a:xfrm>
-            <a:off x="457200" y="5029200"/>
-            <a:ext cx="5486400" cy="457200"/>
+          <p:cNvPr id="18" name="TextBox 17"/>
+          <p:cNvSpPr txBox="1"/>
+          <p:nvPr/>
+        </p:nvSpPr>
+        <p:spPr>
+          <a:xfrm>
+            <a:off x="502920" y="5513832"/>
+            <a:ext cx="5394960" cy="365760"/>
           </a:xfrm>
           <a:prstGeom prst="rect">
             <a:avLst/>
@@ -14325,32 +15148,32 @@
           <a:p>
             <a:pPr algn="l"/>
             <a:r>
-              <a:rPr sz="1400" b="1" i="0">
-                <a:solidFill>
-                  <a:srgbClr val="38BDF8"/>
-                </a:solidFill>
-              </a:rPr>
-              <a:t>Knoxportal@samsung.com</a:t>
-            </a:r>
-          </a:p>
-        </p:txBody>
-      </p:sp>
-      <p:sp>
-        <p:nvSpPr>
-          <p:cNvPr id="23" name="Rectangle 22"/>
+              <a:rPr sz="1100" b="0" i="0">
+                <a:solidFill>
+                  <a:srgbClr val="FFFFFF"/>
+                </a:solidFill>
+              </a:rPr>
+              <a:t>📌 cardContent 줄바꿈:  \n  사용 (실제 문자열에서 \\n → \n)</a:t>
+            </a:r>
+          </a:p>
+        </p:txBody>
+      </p:sp>
+      <p:sp>
+        <p:nvSpPr>
+          <p:cNvPr id="19" name="Rectangle 18"/>
           <p:cNvSpPr/>
           <p:nvPr/>
         </p:nvSpPr>
         <p:spPr>
           <a:xfrm>
-            <a:off x="365760" y="5577840"/>
-            <a:ext cx="5943600" cy="457200"/>
-          </a:xfrm>
-          <a:prstGeom prst="rect">
-            <a:avLst/>
-          </a:prstGeom>
-          <a:solidFill>
-            <a:srgbClr val="1E293B"/>
+            <a:off x="6336792" y="1508760"/>
+            <a:ext cx="5577840" cy="292608"/>
+          </a:xfrm>
+          <a:prstGeom prst="rect">
+            <a:avLst/>
+          </a:prstGeom>
+          <a:solidFill>
+            <a:srgbClr val="4A276E"/>
           </a:solidFill>
           <a:ln>
             <a:noFill/>
@@ -14380,20 +15203,54 @@
       </p:sp>
       <p:sp>
         <p:nvSpPr>
-          <p:cNvPr id="24" name="Rectangle 23"/>
+          <p:cNvPr id="20" name="TextBox 19"/>
+          <p:cNvSpPr txBox="1"/>
+          <p:nvPr/>
+        </p:nvSpPr>
+        <p:spPr>
+          <a:xfrm>
+            <a:off x="6336792" y="1508760"/>
+            <a:ext cx="5577840" cy="292608"/>
+          </a:xfrm>
+          <a:prstGeom prst="rect">
+            <a:avLst/>
+          </a:prstGeom>
+          <a:noFill/>
+        </p:spPr>
+        <p:txBody>
+          <a:bodyPr wrap="square">
+            <a:spAutoFit/>
+          </a:bodyPr>
+          <a:lstStyle/>
+          <a:p>
+            <a:pPr algn="l"/>
+            <a:r>
+              <a:rPr sz="1100" b="1" i="0">
+                <a:solidFill>
+                  <a:srgbClr val="FFFFFF"/>
+                </a:solidFill>
+              </a:rPr>
+              <a:t>  📎  PDF 파일 전송 (업로드 → 메시지)</a:t>
+            </a:r>
+          </a:p>
+        </p:txBody>
+      </p:sp>
+      <p:sp>
+        <p:nvSpPr>
+          <p:cNvPr id="21" name="Rectangle 20"/>
           <p:cNvSpPr/>
           <p:nvPr/>
         </p:nvSpPr>
         <p:spPr>
           <a:xfrm>
-            <a:off x="365760" y="5577840"/>
-            <a:ext cx="54864" cy="457200"/>
-          </a:xfrm>
-          <a:prstGeom prst="rect">
-            <a:avLst/>
-          </a:prstGeom>
-          <a:solidFill>
-            <a:srgbClr val="60A5FA"/>
+            <a:off x="6336792" y="1801368"/>
+            <a:ext cx="5577840" cy="3520440"/>
+          </a:xfrm>
+          <a:prstGeom prst="rect">
+            <a:avLst/>
+          </a:prstGeom>
+          <a:solidFill>
+            <a:srgbClr val="1E293B"/>
           </a:solidFill>
           <a:ln>
             <a:noFill/>
@@ -14423,14 +15280,57 @@
       </p:sp>
       <p:sp>
         <p:nvSpPr>
-          <p:cNvPr id="25" name="TextBox 24"/>
-          <p:cNvSpPr txBox="1"/>
-          <p:nvPr/>
-        </p:nvSpPr>
-        <p:spPr>
-          <a:xfrm>
-            <a:off x="502920" y="5632704"/>
-            <a:ext cx="5760720" cy="365760"/>
+          <p:cNvPr id="22" name="Rectangle 21"/>
+          <p:cNvSpPr/>
+          <p:nvPr/>
+        </p:nvSpPr>
+        <p:spPr>
+          <a:xfrm>
+            <a:off x="6336792" y="1801368"/>
+            <a:ext cx="45720" cy="3520440"/>
+          </a:xfrm>
+          <a:prstGeom prst="rect">
+            <a:avLst/>
+          </a:prstGeom>
+          <a:solidFill>
+            <a:srgbClr val="9B5DE5"/>
+          </a:solidFill>
+          <a:ln>
+            <a:noFill/>
+          </a:ln>
+        </p:spPr>
+        <p:style>
+          <a:lnRef idx="1">
+            <a:schemeClr val="accent1"/>
+          </a:lnRef>
+          <a:fillRef idx="3">
+            <a:schemeClr val="accent1"/>
+          </a:fillRef>
+          <a:effectRef idx="2">
+            <a:schemeClr val="accent1"/>
+          </a:effectRef>
+          <a:fontRef idx="minor">
+            <a:schemeClr val="lt1"/>
+          </a:fontRef>
+        </p:style>
+        <p:txBody>
+          <a:bodyPr rtlCol="0" anchor="ctr"/>
+          <a:lstStyle/>
+          <a:p>
+            <a:pPr algn="ctr"/>
+          </a:p>
+        </p:txBody>
+      </p:sp>
+      <p:sp>
+        <p:nvSpPr>
+          <p:cNvPr id="23" name="TextBox 22"/>
+          <p:cNvSpPr txBox="1"/>
+          <p:nvPr/>
+        </p:nvSpPr>
+        <p:spPr>
+          <a:xfrm>
+            <a:off x="6446520" y="1847088"/>
+            <a:ext cx="5413248" cy="3456432"/>
           </a:xfrm>
           <a:prstGeom prst="rect">
             <a:avLst/>
@@ -14445,12 +15345,149 @@
           <a:p>
             <a:pPr algn="l"/>
             <a:r>
+              <a:rPr sz="950" b="0" i="0">
+                <a:solidFill>
+                  <a:srgbClr val="93C5FD"/>
+                </a:solidFill>
+              </a:rPr>
+              <a:t># ① 파일 업로드 → fileId 획득
+with open("fa_report.pdf", "rb") as f:
+    res = requests.post(
+        f"{BASE}/messenger/bot/v1/file",
+        headers={**headers, "x-device-id": device_id},
+        files={"file": ("fa_report.pdf", f, "application/pdf")},
+    )
+file_id = res.json()["fileId"]
+# ② 파일 메시지 전송
+res = requests.post(
+    f"{BASE}/messenger/bot/v1/message",
+    headers={**headers, "x-device-id": device_id},
+    json={
+        "roomId": room_id,
+        "messageType": "FILE",
+        "fileId": file_id,
+    },
+)</a:t>
+            </a:r>
+          </a:p>
+        </p:txBody>
+      </p:sp>
+      <p:sp>
+        <p:nvSpPr>
+          <p:cNvPr id="24" name="Rectangle 23"/>
+          <p:cNvSpPr/>
+          <p:nvPr/>
+        </p:nvSpPr>
+        <p:spPr>
+          <a:xfrm>
+            <a:off x="6336792" y="5440680"/>
+            <a:ext cx="5577840" cy="457200"/>
+          </a:xfrm>
+          <a:prstGeom prst="rect">
+            <a:avLst/>
+          </a:prstGeom>
+          <a:solidFill>
+            <a:srgbClr val="1E293B"/>
+          </a:solidFill>
+          <a:ln>
+            <a:noFill/>
+          </a:ln>
+        </p:spPr>
+        <p:style>
+          <a:lnRef idx="1">
+            <a:schemeClr val="accent1"/>
+          </a:lnRef>
+          <a:fillRef idx="3">
+            <a:schemeClr val="accent1"/>
+          </a:fillRef>
+          <a:effectRef idx="2">
+            <a:schemeClr val="accent1"/>
+          </a:effectRef>
+          <a:fontRef idx="minor">
+            <a:schemeClr val="lt1"/>
+          </a:fontRef>
+        </p:style>
+        <p:txBody>
+          <a:bodyPr rtlCol="0" anchor="ctr"/>
+          <a:lstStyle/>
+          <a:p>
+            <a:pPr algn="ctr"/>
+          </a:p>
+        </p:txBody>
+      </p:sp>
+      <p:sp>
+        <p:nvSpPr>
+          <p:cNvPr id="25" name="Rectangle 24"/>
+          <p:cNvSpPr/>
+          <p:nvPr/>
+        </p:nvSpPr>
+        <p:spPr>
+          <a:xfrm>
+            <a:off x="6336792" y="5440680"/>
+            <a:ext cx="54864" cy="457200"/>
+          </a:xfrm>
+          <a:prstGeom prst="rect">
+            <a:avLst/>
+          </a:prstGeom>
+          <a:solidFill>
+            <a:srgbClr val="9B5DE5"/>
+          </a:solidFill>
+          <a:ln>
+            <a:noFill/>
+          </a:ln>
+        </p:spPr>
+        <p:style>
+          <a:lnRef idx="1">
+            <a:schemeClr val="accent1"/>
+          </a:lnRef>
+          <a:fillRef idx="3">
+            <a:schemeClr val="accent1"/>
+          </a:fillRef>
+          <a:effectRef idx="2">
+            <a:schemeClr val="accent1"/>
+          </a:effectRef>
+          <a:fontRef idx="minor">
+            <a:schemeClr val="lt1"/>
+          </a:fontRef>
+        </p:style>
+        <p:txBody>
+          <a:bodyPr rtlCol="0" anchor="ctr"/>
+          <a:lstStyle/>
+          <a:p>
+            <a:pPr algn="ctr"/>
+          </a:p>
+        </p:txBody>
+      </p:sp>
+      <p:sp>
+        <p:nvSpPr>
+          <p:cNvPr id="26" name="TextBox 25"/>
+          <p:cNvSpPr txBox="1"/>
+          <p:nvPr/>
+        </p:nvSpPr>
+        <p:spPr>
+          <a:xfrm>
+            <a:off x="6473952" y="5495544"/>
+            <a:ext cx="5394960" cy="365760"/>
+          </a:xfrm>
+          <a:prstGeom prst="rect">
+            <a:avLst/>
+          </a:prstGeom>
+          <a:noFill/>
+        </p:spPr>
+        <p:txBody>
+          <a:bodyPr wrap="square">
+            <a:spAutoFit/>
+          </a:bodyPr>
+          <a:lstStyle/>
+          <a:p>
+            <a:pPr algn="l"/>
+            <a:r>
               <a:rPr sz="1100" b="0" i="0">
                 <a:solidFill>
                   <a:srgbClr val="FFFFFF"/>
                 </a:solidFill>
               </a:rPr>
-              <a:t>💡 Knox Portal 내 물음표(?) 버튼 → Knox Support → Teams 메뉴</a:t>
+              <a:t>💡 파일 크기 제한 및 허용 확장자는 Knox Developer Center 문서를 확인하세요</a:t>
             </a:r>
           </a:p>
         </p:txBody>

</xml_diff>